<commit_message>
C, C++, C# logo added
</commit_message>
<xml_diff>
--- a/tepk2924_Custon_Icon.pptx
+++ b/tepk2924_Custon_Icon.pptx
@@ -27023,6 +27023,1914 @@
           </p:txBody>
         </p:sp>
       </p:grpSp>
+      <p:grpSp>
+        <p:nvGrpSpPr>
+          <p:cNvPr id="58" name="그룹 57">
+            <a:extLst>
+              <a:ext uri="{FF2B5EF4-FFF2-40B4-BE49-F238E27FC236}">
+                <a16:creationId xmlns:a16="http://schemas.microsoft.com/office/drawing/2014/main" id="{87FC78A2-83E4-F2F4-04A3-A2323CB9E5FE}"/>
+              </a:ext>
+            </a:extLst>
+          </p:cNvPr>
+          <p:cNvGrpSpPr/>
+          <p:nvPr/>
+        </p:nvGrpSpPr>
+        <p:grpSpPr>
+          <a:xfrm>
+            <a:off x="225539" y="2339329"/>
+            <a:ext cx="1440000" cy="1440000"/>
+            <a:chOff x="1419986" y="2444584"/>
+            <a:chExt cx="1440000" cy="1440000"/>
+          </a:xfrm>
+        </p:grpSpPr>
+        <p:sp>
+          <p:nvSpPr>
+            <p:cNvPr id="22" name="팔각형 21">
+              <a:extLst>
+                <a:ext uri="{FF2B5EF4-FFF2-40B4-BE49-F238E27FC236}">
+                  <a16:creationId xmlns:a16="http://schemas.microsoft.com/office/drawing/2014/main" id="{A92E910D-CA44-9EE0-1D14-890AF08DFED1}"/>
+                </a:ext>
+              </a:extLst>
+            </p:cNvPr>
+            <p:cNvSpPr/>
+            <p:nvPr/>
+          </p:nvSpPr>
+          <p:spPr>
+            <a:xfrm>
+              <a:off x="1419986" y="2444584"/>
+              <a:ext cx="1440000" cy="1440000"/>
+            </a:xfrm>
+            <a:prstGeom prst="octagon">
+              <a:avLst/>
+            </a:prstGeom>
+            <a:solidFill>
+              <a:srgbClr val="390091"/>
+            </a:solidFill>
+            <a:ln>
+              <a:noFill/>
+            </a:ln>
+          </p:spPr>
+          <p:style>
+            <a:lnRef idx="2">
+              <a:schemeClr val="accent1">
+                <a:shade val="15000"/>
+              </a:schemeClr>
+            </a:lnRef>
+            <a:fillRef idx="1">
+              <a:schemeClr val="accent1"/>
+            </a:fillRef>
+            <a:effectRef idx="0">
+              <a:schemeClr val="accent1"/>
+            </a:effectRef>
+            <a:fontRef idx="minor">
+              <a:schemeClr val="lt1"/>
+            </a:fontRef>
+          </p:style>
+          <p:txBody>
+            <a:bodyPr rtlCol="0" anchor="ctr"/>
+            <a:lstStyle/>
+            <a:p>
+              <a:pPr algn="ctr"/>
+              <a:endParaRPr lang="ko-KR" altLang="en-US"/>
+            </a:p>
+          </p:txBody>
+        </p:sp>
+        <p:sp>
+          <p:nvSpPr>
+            <p:cNvPr id="39" name="자유형: 도형 38">
+              <a:extLst>
+                <a:ext uri="{FF2B5EF4-FFF2-40B4-BE49-F238E27FC236}">
+                  <a16:creationId xmlns:a16="http://schemas.microsoft.com/office/drawing/2014/main" id="{8FA65468-2752-3DF7-431C-077F2E2A297E}"/>
+                </a:ext>
+              </a:extLst>
+            </p:cNvPr>
+            <p:cNvSpPr/>
+            <p:nvPr/>
+          </p:nvSpPr>
+          <p:spPr>
+            <a:xfrm rot="16200000">
+              <a:off x="1423927" y="2655465"/>
+              <a:ext cx="1229119" cy="1229119"/>
+            </a:xfrm>
+            <a:custGeom>
+              <a:avLst/>
+              <a:gdLst>
+                <a:gd name="connsiteX0" fmla="*/ 421762 w 1229119"/>
+                <a:gd name="connsiteY0" fmla="*/ 0 h 1229119"/>
+                <a:gd name="connsiteX1" fmla="*/ 1018238 w 1229119"/>
+                <a:gd name="connsiteY1" fmla="*/ 0 h 1229119"/>
+                <a:gd name="connsiteX2" fmla="*/ 1229119 w 1229119"/>
+                <a:gd name="connsiteY2" fmla="*/ 210881 h 1229119"/>
+                <a:gd name="connsiteX3" fmla="*/ 210881 w 1229119"/>
+                <a:gd name="connsiteY3" fmla="*/ 1229119 h 1229119"/>
+                <a:gd name="connsiteX4" fmla="*/ 0 w 1229119"/>
+                <a:gd name="connsiteY4" fmla="*/ 1018238 h 1229119"/>
+                <a:gd name="connsiteX5" fmla="*/ 0 w 1229119"/>
+                <a:gd name="connsiteY5" fmla="*/ 421762 h 1229119"/>
+              </a:gdLst>
+              <a:ahLst/>
+              <a:cxnLst>
+                <a:cxn ang="0">
+                  <a:pos x="connsiteX0" y="connsiteY0"/>
+                </a:cxn>
+                <a:cxn ang="0">
+                  <a:pos x="connsiteX1" y="connsiteY1"/>
+                </a:cxn>
+                <a:cxn ang="0">
+                  <a:pos x="connsiteX2" y="connsiteY2"/>
+                </a:cxn>
+                <a:cxn ang="0">
+                  <a:pos x="connsiteX3" y="connsiteY3"/>
+                </a:cxn>
+                <a:cxn ang="0">
+                  <a:pos x="connsiteX4" y="connsiteY4"/>
+                </a:cxn>
+                <a:cxn ang="0">
+                  <a:pos x="connsiteX5" y="connsiteY5"/>
+                </a:cxn>
+              </a:cxnLst>
+              <a:rect l="l" t="t" r="r" b="b"/>
+              <a:pathLst>
+                <a:path w="1229119" h="1229119">
+                  <a:moveTo>
+                    <a:pt x="421762" y="0"/>
+                  </a:moveTo>
+                  <a:lnTo>
+                    <a:pt x="1018238" y="0"/>
+                  </a:lnTo>
+                  <a:lnTo>
+                    <a:pt x="1229119" y="210881"/>
+                  </a:lnTo>
+                  <a:lnTo>
+                    <a:pt x="210881" y="1229119"/>
+                  </a:lnTo>
+                  <a:lnTo>
+                    <a:pt x="0" y="1018238"/>
+                  </a:lnTo>
+                  <a:lnTo>
+                    <a:pt x="0" y="421762"/>
+                  </a:lnTo>
+                  <a:close/>
+                </a:path>
+              </a:pathLst>
+            </a:custGeom>
+            <a:solidFill>
+              <a:srgbClr val="280068"/>
+            </a:solidFill>
+            <a:ln>
+              <a:noFill/>
+            </a:ln>
+          </p:spPr>
+          <p:style>
+            <a:lnRef idx="2">
+              <a:schemeClr val="accent1">
+                <a:shade val="15000"/>
+              </a:schemeClr>
+            </a:lnRef>
+            <a:fillRef idx="1">
+              <a:schemeClr val="accent1"/>
+            </a:fillRef>
+            <a:effectRef idx="0">
+              <a:schemeClr val="accent1"/>
+            </a:effectRef>
+            <a:fontRef idx="minor">
+              <a:schemeClr val="lt1"/>
+            </a:fontRef>
+          </p:style>
+          <p:txBody>
+            <a:bodyPr wrap="square" rtlCol="0" anchor="ctr">
+              <a:noAutofit/>
+            </a:bodyPr>
+            <a:lstStyle/>
+            <a:p>
+              <a:pPr algn="ctr"/>
+              <a:endParaRPr lang="ko-KR" altLang="en-US"/>
+            </a:p>
+          </p:txBody>
+        </p:sp>
+        <p:sp>
+          <p:nvSpPr>
+            <p:cNvPr id="33" name="자유형: 도형 32">
+              <a:extLst>
+                <a:ext uri="{FF2B5EF4-FFF2-40B4-BE49-F238E27FC236}">
+                  <a16:creationId xmlns:a16="http://schemas.microsoft.com/office/drawing/2014/main" id="{2A42578F-6C9D-DDE7-69E4-4DAEBAEA34C4}"/>
+                </a:ext>
+              </a:extLst>
+            </p:cNvPr>
+            <p:cNvSpPr/>
+            <p:nvPr/>
+          </p:nvSpPr>
+          <p:spPr>
+            <a:xfrm>
+              <a:off x="1420413" y="2445934"/>
+              <a:ext cx="1227600" cy="1229119"/>
+            </a:xfrm>
+            <a:custGeom>
+              <a:avLst/>
+              <a:gdLst>
+                <a:gd name="connsiteX0" fmla="*/ 421762 w 1229119"/>
+                <a:gd name="connsiteY0" fmla="*/ 0 h 1229119"/>
+                <a:gd name="connsiteX1" fmla="*/ 1018238 w 1229119"/>
+                <a:gd name="connsiteY1" fmla="*/ 0 h 1229119"/>
+                <a:gd name="connsiteX2" fmla="*/ 1229119 w 1229119"/>
+                <a:gd name="connsiteY2" fmla="*/ 210881 h 1229119"/>
+                <a:gd name="connsiteX3" fmla="*/ 210881 w 1229119"/>
+                <a:gd name="connsiteY3" fmla="*/ 1229119 h 1229119"/>
+                <a:gd name="connsiteX4" fmla="*/ 0 w 1229119"/>
+                <a:gd name="connsiteY4" fmla="*/ 1018238 h 1229119"/>
+                <a:gd name="connsiteX5" fmla="*/ 0 w 1229119"/>
+                <a:gd name="connsiteY5" fmla="*/ 421762 h 1229119"/>
+              </a:gdLst>
+              <a:ahLst/>
+              <a:cxnLst>
+                <a:cxn ang="0">
+                  <a:pos x="connsiteX0" y="connsiteY0"/>
+                </a:cxn>
+                <a:cxn ang="0">
+                  <a:pos x="connsiteX1" y="connsiteY1"/>
+                </a:cxn>
+                <a:cxn ang="0">
+                  <a:pos x="connsiteX2" y="connsiteY2"/>
+                </a:cxn>
+                <a:cxn ang="0">
+                  <a:pos x="connsiteX3" y="connsiteY3"/>
+                </a:cxn>
+                <a:cxn ang="0">
+                  <a:pos x="connsiteX4" y="connsiteY4"/>
+                </a:cxn>
+                <a:cxn ang="0">
+                  <a:pos x="connsiteX5" y="connsiteY5"/>
+                </a:cxn>
+              </a:cxnLst>
+              <a:rect l="l" t="t" r="r" b="b"/>
+              <a:pathLst>
+                <a:path w="1229119" h="1229119">
+                  <a:moveTo>
+                    <a:pt x="421762" y="0"/>
+                  </a:moveTo>
+                  <a:lnTo>
+                    <a:pt x="1018238" y="0"/>
+                  </a:lnTo>
+                  <a:lnTo>
+                    <a:pt x="1229119" y="210881"/>
+                  </a:lnTo>
+                  <a:lnTo>
+                    <a:pt x="210881" y="1229119"/>
+                  </a:lnTo>
+                  <a:lnTo>
+                    <a:pt x="0" y="1018238"/>
+                  </a:lnTo>
+                  <a:lnTo>
+                    <a:pt x="0" y="421762"/>
+                  </a:lnTo>
+                  <a:close/>
+                </a:path>
+              </a:pathLst>
+            </a:custGeom>
+            <a:solidFill>
+              <a:srgbClr val="A179DC"/>
+            </a:solidFill>
+            <a:ln>
+              <a:noFill/>
+            </a:ln>
+          </p:spPr>
+          <p:style>
+            <a:lnRef idx="2">
+              <a:schemeClr val="accent1">
+                <a:shade val="15000"/>
+              </a:schemeClr>
+            </a:lnRef>
+            <a:fillRef idx="1">
+              <a:schemeClr val="accent1"/>
+            </a:fillRef>
+            <a:effectRef idx="0">
+              <a:schemeClr val="accent1"/>
+            </a:effectRef>
+            <a:fontRef idx="minor">
+              <a:schemeClr val="lt1"/>
+            </a:fontRef>
+          </p:style>
+          <p:txBody>
+            <a:bodyPr wrap="square" rtlCol="0" anchor="ctr">
+              <a:noAutofit/>
+            </a:bodyPr>
+            <a:lstStyle/>
+            <a:p>
+              <a:pPr algn="ctr"/>
+              <a:endParaRPr lang="ko-KR" altLang="en-US"/>
+            </a:p>
+          </p:txBody>
+        </p:sp>
+        <p:sp>
+          <p:nvSpPr>
+            <p:cNvPr id="47" name="자유형: 도형 46">
+              <a:extLst>
+                <a:ext uri="{FF2B5EF4-FFF2-40B4-BE49-F238E27FC236}">
+                  <a16:creationId xmlns:a16="http://schemas.microsoft.com/office/drawing/2014/main" id="{81FB760A-9CFF-B441-F997-FEC03F046361}"/>
+                </a:ext>
+              </a:extLst>
+            </p:cNvPr>
+            <p:cNvSpPr/>
+            <p:nvPr/>
+          </p:nvSpPr>
+          <p:spPr>
+            <a:xfrm>
+              <a:off x="1636984" y="2655464"/>
+              <a:ext cx="864095" cy="1011030"/>
+            </a:xfrm>
+            <a:custGeom>
+              <a:avLst/>
+              <a:gdLst>
+                <a:gd name="connsiteX0" fmla="*/ 296121 w 864095"/>
+                <a:gd name="connsiteY0" fmla="*/ 0 h 1011030"/>
+                <a:gd name="connsiteX1" fmla="*/ 714909 w 864095"/>
+                <a:gd name="connsiteY1" fmla="*/ 0 h 1011030"/>
+                <a:gd name="connsiteX2" fmla="*/ 864095 w 864095"/>
+                <a:gd name="connsiteY2" fmla="*/ 149186 h 1011030"/>
+                <a:gd name="connsiteX3" fmla="*/ 703511 w 864095"/>
+                <a:gd name="connsiteY3" fmla="*/ 309771 h 1011030"/>
+                <a:gd name="connsiteX4" fmla="*/ 620840 w 864095"/>
+                <a:gd name="connsiteY4" fmla="*/ 227100 h 1011030"/>
+                <a:gd name="connsiteX5" fmla="*/ 390190 w 864095"/>
+                <a:gd name="connsiteY5" fmla="*/ 227100 h 1011030"/>
+                <a:gd name="connsiteX6" fmla="*/ 227100 w 864095"/>
+                <a:gd name="connsiteY6" fmla="*/ 390190 h 1011030"/>
+                <a:gd name="connsiteX7" fmla="*/ 227100 w 864095"/>
+                <a:gd name="connsiteY7" fmla="*/ 620840 h 1011030"/>
+                <a:gd name="connsiteX8" fmla="*/ 390190 w 864095"/>
+                <a:gd name="connsiteY8" fmla="*/ 783930 h 1011030"/>
+                <a:gd name="connsiteX9" fmla="*/ 620840 w 864095"/>
+                <a:gd name="connsiteY9" fmla="*/ 783930 h 1011030"/>
+                <a:gd name="connsiteX10" fmla="*/ 703511 w 864095"/>
+                <a:gd name="connsiteY10" fmla="*/ 701260 h 1011030"/>
+                <a:gd name="connsiteX11" fmla="*/ 864095 w 864095"/>
+                <a:gd name="connsiteY11" fmla="*/ 861844 h 1011030"/>
+                <a:gd name="connsiteX12" fmla="*/ 714909 w 864095"/>
+                <a:gd name="connsiteY12" fmla="*/ 1011030 h 1011030"/>
+                <a:gd name="connsiteX13" fmla="*/ 296121 w 864095"/>
+                <a:gd name="connsiteY13" fmla="*/ 1011030 h 1011030"/>
+                <a:gd name="connsiteX14" fmla="*/ 0 w 864095"/>
+                <a:gd name="connsiteY14" fmla="*/ 714909 h 1011030"/>
+                <a:gd name="connsiteX15" fmla="*/ 0 w 864095"/>
+                <a:gd name="connsiteY15" fmla="*/ 296121 h 1011030"/>
+              </a:gdLst>
+              <a:ahLst/>
+              <a:cxnLst>
+                <a:cxn ang="0">
+                  <a:pos x="connsiteX0" y="connsiteY0"/>
+                </a:cxn>
+                <a:cxn ang="0">
+                  <a:pos x="connsiteX1" y="connsiteY1"/>
+                </a:cxn>
+                <a:cxn ang="0">
+                  <a:pos x="connsiteX2" y="connsiteY2"/>
+                </a:cxn>
+                <a:cxn ang="0">
+                  <a:pos x="connsiteX3" y="connsiteY3"/>
+                </a:cxn>
+                <a:cxn ang="0">
+                  <a:pos x="connsiteX4" y="connsiteY4"/>
+                </a:cxn>
+                <a:cxn ang="0">
+                  <a:pos x="connsiteX5" y="connsiteY5"/>
+                </a:cxn>
+                <a:cxn ang="0">
+                  <a:pos x="connsiteX6" y="connsiteY6"/>
+                </a:cxn>
+                <a:cxn ang="0">
+                  <a:pos x="connsiteX7" y="connsiteY7"/>
+                </a:cxn>
+                <a:cxn ang="0">
+                  <a:pos x="connsiteX8" y="connsiteY8"/>
+                </a:cxn>
+                <a:cxn ang="0">
+                  <a:pos x="connsiteX9" y="connsiteY9"/>
+                </a:cxn>
+                <a:cxn ang="0">
+                  <a:pos x="connsiteX10" y="connsiteY10"/>
+                </a:cxn>
+                <a:cxn ang="0">
+                  <a:pos x="connsiteX11" y="connsiteY11"/>
+                </a:cxn>
+                <a:cxn ang="0">
+                  <a:pos x="connsiteX12" y="connsiteY12"/>
+                </a:cxn>
+                <a:cxn ang="0">
+                  <a:pos x="connsiteX13" y="connsiteY13"/>
+                </a:cxn>
+                <a:cxn ang="0">
+                  <a:pos x="connsiteX14" y="connsiteY14"/>
+                </a:cxn>
+                <a:cxn ang="0">
+                  <a:pos x="connsiteX15" y="connsiteY15"/>
+                </a:cxn>
+              </a:cxnLst>
+              <a:rect l="l" t="t" r="r" b="b"/>
+              <a:pathLst>
+                <a:path w="864095" h="1011030">
+                  <a:moveTo>
+                    <a:pt x="296121" y="0"/>
+                  </a:moveTo>
+                  <a:lnTo>
+                    <a:pt x="714909" y="0"/>
+                  </a:lnTo>
+                  <a:lnTo>
+                    <a:pt x="864095" y="149186"/>
+                  </a:lnTo>
+                  <a:lnTo>
+                    <a:pt x="703511" y="309771"/>
+                  </a:lnTo>
+                  <a:lnTo>
+                    <a:pt x="620840" y="227100"/>
+                  </a:lnTo>
+                  <a:lnTo>
+                    <a:pt x="390190" y="227100"/>
+                  </a:lnTo>
+                  <a:lnTo>
+                    <a:pt x="227100" y="390190"/>
+                  </a:lnTo>
+                  <a:lnTo>
+                    <a:pt x="227100" y="620840"/>
+                  </a:lnTo>
+                  <a:lnTo>
+                    <a:pt x="390190" y="783930"/>
+                  </a:lnTo>
+                  <a:lnTo>
+                    <a:pt x="620840" y="783930"/>
+                  </a:lnTo>
+                  <a:lnTo>
+                    <a:pt x="703511" y="701260"/>
+                  </a:lnTo>
+                  <a:lnTo>
+                    <a:pt x="864095" y="861844"/>
+                  </a:lnTo>
+                  <a:lnTo>
+                    <a:pt x="714909" y="1011030"/>
+                  </a:lnTo>
+                  <a:lnTo>
+                    <a:pt x="296121" y="1011030"/>
+                  </a:lnTo>
+                  <a:lnTo>
+                    <a:pt x="0" y="714909"/>
+                  </a:lnTo>
+                  <a:lnTo>
+                    <a:pt x="0" y="296121"/>
+                  </a:lnTo>
+                  <a:close/>
+                </a:path>
+              </a:pathLst>
+            </a:custGeom>
+            <a:solidFill>
+              <a:schemeClr val="bg1"/>
+            </a:solidFill>
+            <a:ln>
+              <a:noFill/>
+            </a:ln>
+          </p:spPr>
+          <p:style>
+            <a:lnRef idx="2">
+              <a:schemeClr val="accent1">
+                <a:shade val="15000"/>
+              </a:schemeClr>
+            </a:lnRef>
+            <a:fillRef idx="1">
+              <a:schemeClr val="accent1"/>
+            </a:fillRef>
+            <a:effectRef idx="0">
+              <a:schemeClr val="accent1"/>
+            </a:effectRef>
+            <a:fontRef idx="minor">
+              <a:schemeClr val="lt1"/>
+            </a:fontRef>
+          </p:style>
+          <p:txBody>
+            <a:bodyPr wrap="square" rtlCol="0" anchor="ctr">
+              <a:noAutofit/>
+            </a:bodyPr>
+            <a:lstStyle/>
+            <a:p>
+              <a:pPr algn="ctr"/>
+              <a:endParaRPr lang="ko-KR" altLang="en-US"/>
+            </a:p>
+          </p:txBody>
+        </p:sp>
+        <p:sp>
+          <p:nvSpPr>
+            <p:cNvPr id="49" name="팔각형 48">
+              <a:extLst>
+                <a:ext uri="{FF2B5EF4-FFF2-40B4-BE49-F238E27FC236}">
+                  <a16:creationId xmlns:a16="http://schemas.microsoft.com/office/drawing/2014/main" id="{63607ABF-EDC9-28BE-ECB5-070978EA690B}"/>
+                </a:ext>
+              </a:extLst>
+            </p:cNvPr>
+            <p:cNvSpPr/>
+            <p:nvPr/>
+          </p:nvSpPr>
+          <p:spPr>
+            <a:xfrm>
+              <a:off x="2440948" y="2988045"/>
+              <a:ext cx="45720" cy="345868"/>
+            </a:xfrm>
+            <a:prstGeom prst="octagon">
+              <a:avLst/>
+            </a:prstGeom>
+            <a:solidFill>
+              <a:schemeClr val="bg1"/>
+            </a:solidFill>
+            <a:ln>
+              <a:noFill/>
+            </a:ln>
+          </p:spPr>
+          <p:style>
+            <a:lnRef idx="2">
+              <a:schemeClr val="accent1">
+                <a:shade val="15000"/>
+              </a:schemeClr>
+            </a:lnRef>
+            <a:fillRef idx="1">
+              <a:schemeClr val="accent1"/>
+            </a:fillRef>
+            <a:effectRef idx="0">
+              <a:schemeClr val="accent1"/>
+            </a:effectRef>
+            <a:fontRef idx="minor">
+              <a:schemeClr val="lt1"/>
+            </a:fontRef>
+          </p:style>
+          <p:txBody>
+            <a:bodyPr wrap="square" rtlCol="0" anchor="ctr">
+              <a:noAutofit/>
+            </a:bodyPr>
+            <a:lstStyle/>
+            <a:p>
+              <a:pPr algn="ctr"/>
+              <a:endParaRPr lang="ko-KR" altLang="en-US"/>
+            </a:p>
+          </p:txBody>
+        </p:sp>
+        <p:sp>
+          <p:nvSpPr>
+            <p:cNvPr id="50" name="팔각형 49">
+              <a:extLst>
+                <a:ext uri="{FF2B5EF4-FFF2-40B4-BE49-F238E27FC236}">
+                  <a16:creationId xmlns:a16="http://schemas.microsoft.com/office/drawing/2014/main" id="{DF670093-B666-C4E0-381D-1A7304415EF0}"/>
+                </a:ext>
+              </a:extLst>
+            </p:cNvPr>
+            <p:cNvSpPr/>
+            <p:nvPr/>
+          </p:nvSpPr>
+          <p:spPr>
+            <a:xfrm>
+              <a:off x="2566926" y="2988045"/>
+              <a:ext cx="45720" cy="345868"/>
+            </a:xfrm>
+            <a:prstGeom prst="octagon">
+              <a:avLst/>
+            </a:prstGeom>
+            <a:solidFill>
+              <a:schemeClr val="bg1"/>
+            </a:solidFill>
+            <a:ln>
+              <a:noFill/>
+            </a:ln>
+          </p:spPr>
+          <p:style>
+            <a:lnRef idx="2">
+              <a:schemeClr val="accent1">
+                <a:shade val="15000"/>
+              </a:schemeClr>
+            </a:lnRef>
+            <a:fillRef idx="1">
+              <a:schemeClr val="accent1"/>
+            </a:fillRef>
+            <a:effectRef idx="0">
+              <a:schemeClr val="accent1"/>
+            </a:effectRef>
+            <a:fontRef idx="minor">
+              <a:schemeClr val="lt1"/>
+            </a:fontRef>
+          </p:style>
+          <p:txBody>
+            <a:bodyPr wrap="square" rtlCol="0" anchor="ctr">
+              <a:noAutofit/>
+            </a:bodyPr>
+            <a:lstStyle/>
+            <a:p>
+              <a:pPr algn="ctr"/>
+              <a:endParaRPr lang="ko-KR" altLang="en-US"/>
+            </a:p>
+          </p:txBody>
+        </p:sp>
+        <p:sp>
+          <p:nvSpPr>
+            <p:cNvPr id="55" name="팔각형 54">
+              <a:extLst>
+                <a:ext uri="{FF2B5EF4-FFF2-40B4-BE49-F238E27FC236}">
+                  <a16:creationId xmlns:a16="http://schemas.microsoft.com/office/drawing/2014/main" id="{345FD146-73F3-C235-EC6B-B836006CFDD4}"/>
+                </a:ext>
+              </a:extLst>
+            </p:cNvPr>
+            <p:cNvSpPr/>
+            <p:nvPr/>
+          </p:nvSpPr>
+          <p:spPr>
+            <a:xfrm rot="5400000">
+              <a:off x="2503937" y="2925056"/>
+              <a:ext cx="45720" cy="345868"/>
+            </a:xfrm>
+            <a:prstGeom prst="octagon">
+              <a:avLst/>
+            </a:prstGeom>
+            <a:solidFill>
+              <a:schemeClr val="bg1"/>
+            </a:solidFill>
+            <a:ln>
+              <a:noFill/>
+            </a:ln>
+          </p:spPr>
+          <p:style>
+            <a:lnRef idx="2">
+              <a:schemeClr val="accent1">
+                <a:shade val="15000"/>
+              </a:schemeClr>
+            </a:lnRef>
+            <a:fillRef idx="1">
+              <a:schemeClr val="accent1"/>
+            </a:fillRef>
+            <a:effectRef idx="0">
+              <a:schemeClr val="accent1"/>
+            </a:effectRef>
+            <a:fontRef idx="minor">
+              <a:schemeClr val="lt1"/>
+            </a:fontRef>
+          </p:style>
+          <p:txBody>
+            <a:bodyPr wrap="square" rtlCol="0" anchor="ctr">
+              <a:noAutofit/>
+            </a:bodyPr>
+            <a:lstStyle/>
+            <a:p>
+              <a:pPr algn="ctr"/>
+              <a:endParaRPr lang="ko-KR" altLang="en-US"/>
+            </a:p>
+          </p:txBody>
+        </p:sp>
+        <p:sp>
+          <p:nvSpPr>
+            <p:cNvPr id="56" name="팔각형 55">
+              <a:extLst>
+                <a:ext uri="{FF2B5EF4-FFF2-40B4-BE49-F238E27FC236}">
+                  <a16:creationId xmlns:a16="http://schemas.microsoft.com/office/drawing/2014/main" id="{B25BBBD5-B583-DCF8-C520-4729116F4E15}"/>
+                </a:ext>
+              </a:extLst>
+            </p:cNvPr>
+            <p:cNvSpPr/>
+            <p:nvPr/>
+          </p:nvSpPr>
+          <p:spPr>
+            <a:xfrm rot="5400000">
+              <a:off x="2503937" y="3051034"/>
+              <a:ext cx="45720" cy="345868"/>
+            </a:xfrm>
+            <a:prstGeom prst="octagon">
+              <a:avLst/>
+            </a:prstGeom>
+            <a:solidFill>
+              <a:schemeClr val="bg1"/>
+            </a:solidFill>
+            <a:ln>
+              <a:noFill/>
+            </a:ln>
+          </p:spPr>
+          <p:style>
+            <a:lnRef idx="2">
+              <a:schemeClr val="accent1">
+                <a:shade val="15000"/>
+              </a:schemeClr>
+            </a:lnRef>
+            <a:fillRef idx="1">
+              <a:schemeClr val="accent1"/>
+            </a:fillRef>
+            <a:effectRef idx="0">
+              <a:schemeClr val="accent1"/>
+            </a:effectRef>
+            <a:fontRef idx="minor">
+              <a:schemeClr val="lt1"/>
+            </a:fontRef>
+          </p:style>
+          <p:txBody>
+            <a:bodyPr wrap="square" rtlCol="0" anchor="ctr">
+              <a:noAutofit/>
+            </a:bodyPr>
+            <a:lstStyle/>
+            <a:p>
+              <a:pPr algn="ctr"/>
+              <a:endParaRPr lang="ko-KR" altLang="en-US"/>
+            </a:p>
+          </p:txBody>
+        </p:sp>
+      </p:grpSp>
+      <p:grpSp>
+        <p:nvGrpSpPr>
+          <p:cNvPr id="84" name="그룹 83">
+            <a:extLst>
+              <a:ext uri="{FF2B5EF4-FFF2-40B4-BE49-F238E27FC236}">
+                <a16:creationId xmlns:a16="http://schemas.microsoft.com/office/drawing/2014/main" id="{F55BA362-DFD5-07AF-0FAD-CB4E9DA0A54F}"/>
+              </a:ext>
+            </a:extLst>
+          </p:cNvPr>
+          <p:cNvGrpSpPr/>
+          <p:nvPr/>
+        </p:nvGrpSpPr>
+        <p:grpSpPr>
+          <a:xfrm>
+            <a:off x="2149594" y="2339329"/>
+            <a:ext cx="1440000" cy="1440000"/>
+            <a:chOff x="2149594" y="2339329"/>
+            <a:chExt cx="1440000" cy="1440000"/>
+          </a:xfrm>
+        </p:grpSpPr>
+        <p:sp>
+          <p:nvSpPr>
+            <p:cNvPr id="53" name="팔각형 52">
+              <a:extLst>
+                <a:ext uri="{FF2B5EF4-FFF2-40B4-BE49-F238E27FC236}">
+                  <a16:creationId xmlns:a16="http://schemas.microsoft.com/office/drawing/2014/main" id="{099D9C80-3C89-8F0A-930C-F3454D0D3A27}"/>
+                </a:ext>
+              </a:extLst>
+            </p:cNvPr>
+            <p:cNvSpPr/>
+            <p:nvPr/>
+          </p:nvSpPr>
+          <p:spPr>
+            <a:xfrm>
+              <a:off x="2149594" y="2339329"/>
+              <a:ext cx="1440000" cy="1440000"/>
+            </a:xfrm>
+            <a:prstGeom prst="octagon">
+              <a:avLst/>
+            </a:prstGeom>
+            <a:solidFill>
+              <a:srgbClr val="00599C"/>
+            </a:solidFill>
+            <a:ln>
+              <a:noFill/>
+            </a:ln>
+          </p:spPr>
+          <p:style>
+            <a:lnRef idx="2">
+              <a:schemeClr val="accent1">
+                <a:shade val="15000"/>
+              </a:schemeClr>
+            </a:lnRef>
+            <a:fillRef idx="1">
+              <a:schemeClr val="accent1"/>
+            </a:fillRef>
+            <a:effectRef idx="0">
+              <a:schemeClr val="accent1"/>
+            </a:effectRef>
+            <a:fontRef idx="minor">
+              <a:schemeClr val="lt1"/>
+            </a:fontRef>
+          </p:style>
+          <p:txBody>
+            <a:bodyPr rtlCol="0" anchor="ctr"/>
+            <a:lstStyle/>
+            <a:p>
+              <a:pPr algn="ctr"/>
+              <a:endParaRPr lang="ko-KR" altLang="en-US"/>
+            </a:p>
+          </p:txBody>
+        </p:sp>
+        <p:sp>
+          <p:nvSpPr>
+            <p:cNvPr id="54" name="자유형: 도형 53">
+              <a:extLst>
+                <a:ext uri="{FF2B5EF4-FFF2-40B4-BE49-F238E27FC236}">
+                  <a16:creationId xmlns:a16="http://schemas.microsoft.com/office/drawing/2014/main" id="{BFC63661-1066-9228-1062-63E2E43F631F}"/>
+                </a:ext>
+              </a:extLst>
+            </p:cNvPr>
+            <p:cNvSpPr/>
+            <p:nvPr/>
+          </p:nvSpPr>
+          <p:spPr>
+            <a:xfrm rot="16200000">
+              <a:off x="2153535" y="2550210"/>
+              <a:ext cx="1229119" cy="1229119"/>
+            </a:xfrm>
+            <a:custGeom>
+              <a:avLst/>
+              <a:gdLst>
+                <a:gd name="connsiteX0" fmla="*/ 421762 w 1229119"/>
+                <a:gd name="connsiteY0" fmla="*/ 0 h 1229119"/>
+                <a:gd name="connsiteX1" fmla="*/ 1018238 w 1229119"/>
+                <a:gd name="connsiteY1" fmla="*/ 0 h 1229119"/>
+                <a:gd name="connsiteX2" fmla="*/ 1229119 w 1229119"/>
+                <a:gd name="connsiteY2" fmla="*/ 210881 h 1229119"/>
+                <a:gd name="connsiteX3" fmla="*/ 210881 w 1229119"/>
+                <a:gd name="connsiteY3" fmla="*/ 1229119 h 1229119"/>
+                <a:gd name="connsiteX4" fmla="*/ 0 w 1229119"/>
+                <a:gd name="connsiteY4" fmla="*/ 1018238 h 1229119"/>
+                <a:gd name="connsiteX5" fmla="*/ 0 w 1229119"/>
+                <a:gd name="connsiteY5" fmla="*/ 421762 h 1229119"/>
+              </a:gdLst>
+              <a:ahLst/>
+              <a:cxnLst>
+                <a:cxn ang="0">
+                  <a:pos x="connsiteX0" y="connsiteY0"/>
+                </a:cxn>
+                <a:cxn ang="0">
+                  <a:pos x="connsiteX1" y="connsiteY1"/>
+                </a:cxn>
+                <a:cxn ang="0">
+                  <a:pos x="connsiteX2" y="connsiteY2"/>
+                </a:cxn>
+                <a:cxn ang="0">
+                  <a:pos x="connsiteX3" y="connsiteY3"/>
+                </a:cxn>
+                <a:cxn ang="0">
+                  <a:pos x="connsiteX4" y="connsiteY4"/>
+                </a:cxn>
+                <a:cxn ang="0">
+                  <a:pos x="connsiteX5" y="connsiteY5"/>
+                </a:cxn>
+              </a:cxnLst>
+              <a:rect l="l" t="t" r="r" b="b"/>
+              <a:pathLst>
+                <a:path w="1229119" h="1229119">
+                  <a:moveTo>
+                    <a:pt x="421762" y="0"/>
+                  </a:moveTo>
+                  <a:lnTo>
+                    <a:pt x="1018238" y="0"/>
+                  </a:lnTo>
+                  <a:lnTo>
+                    <a:pt x="1229119" y="210881"/>
+                  </a:lnTo>
+                  <a:lnTo>
+                    <a:pt x="210881" y="1229119"/>
+                  </a:lnTo>
+                  <a:lnTo>
+                    <a:pt x="0" y="1018238"/>
+                  </a:lnTo>
+                  <a:lnTo>
+                    <a:pt x="0" y="421762"/>
+                  </a:lnTo>
+                  <a:close/>
+                </a:path>
+              </a:pathLst>
+            </a:custGeom>
+            <a:solidFill>
+              <a:srgbClr val="004482"/>
+            </a:solidFill>
+            <a:ln>
+              <a:noFill/>
+            </a:ln>
+          </p:spPr>
+          <p:style>
+            <a:lnRef idx="2">
+              <a:schemeClr val="accent1">
+                <a:shade val="15000"/>
+              </a:schemeClr>
+            </a:lnRef>
+            <a:fillRef idx="1">
+              <a:schemeClr val="accent1"/>
+            </a:fillRef>
+            <a:effectRef idx="0">
+              <a:schemeClr val="accent1"/>
+            </a:effectRef>
+            <a:fontRef idx="minor">
+              <a:schemeClr val="lt1"/>
+            </a:fontRef>
+          </p:style>
+          <p:txBody>
+            <a:bodyPr wrap="square" rtlCol="0" anchor="ctr">
+              <a:noAutofit/>
+            </a:bodyPr>
+            <a:lstStyle/>
+            <a:p>
+              <a:pPr algn="ctr"/>
+              <a:endParaRPr lang="ko-KR" altLang="en-US"/>
+            </a:p>
+          </p:txBody>
+        </p:sp>
+        <p:sp>
+          <p:nvSpPr>
+            <p:cNvPr id="57" name="자유형: 도형 56">
+              <a:extLst>
+                <a:ext uri="{FF2B5EF4-FFF2-40B4-BE49-F238E27FC236}">
+                  <a16:creationId xmlns:a16="http://schemas.microsoft.com/office/drawing/2014/main" id="{338FCF5B-F69D-D542-DE67-A64368130BB5}"/>
+                </a:ext>
+              </a:extLst>
+            </p:cNvPr>
+            <p:cNvSpPr/>
+            <p:nvPr/>
+          </p:nvSpPr>
+          <p:spPr>
+            <a:xfrm>
+              <a:off x="2150021" y="2340679"/>
+              <a:ext cx="1227600" cy="1229119"/>
+            </a:xfrm>
+            <a:custGeom>
+              <a:avLst/>
+              <a:gdLst>
+                <a:gd name="connsiteX0" fmla="*/ 421762 w 1229119"/>
+                <a:gd name="connsiteY0" fmla="*/ 0 h 1229119"/>
+                <a:gd name="connsiteX1" fmla="*/ 1018238 w 1229119"/>
+                <a:gd name="connsiteY1" fmla="*/ 0 h 1229119"/>
+                <a:gd name="connsiteX2" fmla="*/ 1229119 w 1229119"/>
+                <a:gd name="connsiteY2" fmla="*/ 210881 h 1229119"/>
+                <a:gd name="connsiteX3" fmla="*/ 210881 w 1229119"/>
+                <a:gd name="connsiteY3" fmla="*/ 1229119 h 1229119"/>
+                <a:gd name="connsiteX4" fmla="*/ 0 w 1229119"/>
+                <a:gd name="connsiteY4" fmla="*/ 1018238 h 1229119"/>
+                <a:gd name="connsiteX5" fmla="*/ 0 w 1229119"/>
+                <a:gd name="connsiteY5" fmla="*/ 421762 h 1229119"/>
+              </a:gdLst>
+              <a:ahLst/>
+              <a:cxnLst>
+                <a:cxn ang="0">
+                  <a:pos x="connsiteX0" y="connsiteY0"/>
+                </a:cxn>
+                <a:cxn ang="0">
+                  <a:pos x="connsiteX1" y="connsiteY1"/>
+                </a:cxn>
+                <a:cxn ang="0">
+                  <a:pos x="connsiteX2" y="connsiteY2"/>
+                </a:cxn>
+                <a:cxn ang="0">
+                  <a:pos x="connsiteX3" y="connsiteY3"/>
+                </a:cxn>
+                <a:cxn ang="0">
+                  <a:pos x="connsiteX4" y="connsiteY4"/>
+                </a:cxn>
+                <a:cxn ang="0">
+                  <a:pos x="connsiteX5" y="connsiteY5"/>
+                </a:cxn>
+              </a:cxnLst>
+              <a:rect l="l" t="t" r="r" b="b"/>
+              <a:pathLst>
+                <a:path w="1229119" h="1229119">
+                  <a:moveTo>
+                    <a:pt x="421762" y="0"/>
+                  </a:moveTo>
+                  <a:lnTo>
+                    <a:pt x="1018238" y="0"/>
+                  </a:lnTo>
+                  <a:lnTo>
+                    <a:pt x="1229119" y="210881"/>
+                  </a:lnTo>
+                  <a:lnTo>
+                    <a:pt x="210881" y="1229119"/>
+                  </a:lnTo>
+                  <a:lnTo>
+                    <a:pt x="0" y="1018238"/>
+                  </a:lnTo>
+                  <a:lnTo>
+                    <a:pt x="0" y="421762"/>
+                  </a:lnTo>
+                  <a:close/>
+                </a:path>
+              </a:pathLst>
+            </a:custGeom>
+            <a:solidFill>
+              <a:srgbClr val="659AD2"/>
+            </a:solidFill>
+            <a:ln>
+              <a:noFill/>
+            </a:ln>
+          </p:spPr>
+          <p:style>
+            <a:lnRef idx="2">
+              <a:schemeClr val="accent1">
+                <a:shade val="15000"/>
+              </a:schemeClr>
+            </a:lnRef>
+            <a:fillRef idx="1">
+              <a:schemeClr val="accent1"/>
+            </a:fillRef>
+            <a:effectRef idx="0">
+              <a:schemeClr val="accent1"/>
+            </a:effectRef>
+            <a:fontRef idx="minor">
+              <a:schemeClr val="lt1"/>
+            </a:fontRef>
+          </p:style>
+          <p:txBody>
+            <a:bodyPr wrap="square" rtlCol="0" anchor="ctr">
+              <a:noAutofit/>
+            </a:bodyPr>
+            <a:lstStyle/>
+            <a:p>
+              <a:pPr algn="ctr"/>
+              <a:endParaRPr lang="ko-KR" altLang="en-US"/>
+            </a:p>
+          </p:txBody>
+        </p:sp>
+        <p:sp>
+          <p:nvSpPr>
+            <p:cNvPr id="59" name="자유형: 도형 58">
+              <a:extLst>
+                <a:ext uri="{FF2B5EF4-FFF2-40B4-BE49-F238E27FC236}">
+                  <a16:creationId xmlns:a16="http://schemas.microsoft.com/office/drawing/2014/main" id="{5F421E7F-8F78-01C3-84EB-A6D6796E0E25}"/>
+                </a:ext>
+              </a:extLst>
+            </p:cNvPr>
+            <p:cNvSpPr/>
+            <p:nvPr/>
+          </p:nvSpPr>
+          <p:spPr>
+            <a:xfrm>
+              <a:off x="2366592" y="2550209"/>
+              <a:ext cx="864095" cy="1011030"/>
+            </a:xfrm>
+            <a:custGeom>
+              <a:avLst/>
+              <a:gdLst>
+                <a:gd name="connsiteX0" fmla="*/ 296121 w 864095"/>
+                <a:gd name="connsiteY0" fmla="*/ 0 h 1011030"/>
+                <a:gd name="connsiteX1" fmla="*/ 714909 w 864095"/>
+                <a:gd name="connsiteY1" fmla="*/ 0 h 1011030"/>
+                <a:gd name="connsiteX2" fmla="*/ 864095 w 864095"/>
+                <a:gd name="connsiteY2" fmla="*/ 149186 h 1011030"/>
+                <a:gd name="connsiteX3" fmla="*/ 703511 w 864095"/>
+                <a:gd name="connsiteY3" fmla="*/ 309771 h 1011030"/>
+                <a:gd name="connsiteX4" fmla="*/ 620840 w 864095"/>
+                <a:gd name="connsiteY4" fmla="*/ 227100 h 1011030"/>
+                <a:gd name="connsiteX5" fmla="*/ 390190 w 864095"/>
+                <a:gd name="connsiteY5" fmla="*/ 227100 h 1011030"/>
+                <a:gd name="connsiteX6" fmla="*/ 227100 w 864095"/>
+                <a:gd name="connsiteY6" fmla="*/ 390190 h 1011030"/>
+                <a:gd name="connsiteX7" fmla="*/ 227100 w 864095"/>
+                <a:gd name="connsiteY7" fmla="*/ 620840 h 1011030"/>
+                <a:gd name="connsiteX8" fmla="*/ 390190 w 864095"/>
+                <a:gd name="connsiteY8" fmla="*/ 783930 h 1011030"/>
+                <a:gd name="connsiteX9" fmla="*/ 620840 w 864095"/>
+                <a:gd name="connsiteY9" fmla="*/ 783930 h 1011030"/>
+                <a:gd name="connsiteX10" fmla="*/ 703511 w 864095"/>
+                <a:gd name="connsiteY10" fmla="*/ 701260 h 1011030"/>
+                <a:gd name="connsiteX11" fmla="*/ 864095 w 864095"/>
+                <a:gd name="connsiteY11" fmla="*/ 861844 h 1011030"/>
+                <a:gd name="connsiteX12" fmla="*/ 714909 w 864095"/>
+                <a:gd name="connsiteY12" fmla="*/ 1011030 h 1011030"/>
+                <a:gd name="connsiteX13" fmla="*/ 296121 w 864095"/>
+                <a:gd name="connsiteY13" fmla="*/ 1011030 h 1011030"/>
+                <a:gd name="connsiteX14" fmla="*/ 0 w 864095"/>
+                <a:gd name="connsiteY14" fmla="*/ 714909 h 1011030"/>
+                <a:gd name="connsiteX15" fmla="*/ 0 w 864095"/>
+                <a:gd name="connsiteY15" fmla="*/ 296121 h 1011030"/>
+              </a:gdLst>
+              <a:ahLst/>
+              <a:cxnLst>
+                <a:cxn ang="0">
+                  <a:pos x="connsiteX0" y="connsiteY0"/>
+                </a:cxn>
+                <a:cxn ang="0">
+                  <a:pos x="connsiteX1" y="connsiteY1"/>
+                </a:cxn>
+                <a:cxn ang="0">
+                  <a:pos x="connsiteX2" y="connsiteY2"/>
+                </a:cxn>
+                <a:cxn ang="0">
+                  <a:pos x="connsiteX3" y="connsiteY3"/>
+                </a:cxn>
+                <a:cxn ang="0">
+                  <a:pos x="connsiteX4" y="connsiteY4"/>
+                </a:cxn>
+                <a:cxn ang="0">
+                  <a:pos x="connsiteX5" y="connsiteY5"/>
+                </a:cxn>
+                <a:cxn ang="0">
+                  <a:pos x="connsiteX6" y="connsiteY6"/>
+                </a:cxn>
+                <a:cxn ang="0">
+                  <a:pos x="connsiteX7" y="connsiteY7"/>
+                </a:cxn>
+                <a:cxn ang="0">
+                  <a:pos x="connsiteX8" y="connsiteY8"/>
+                </a:cxn>
+                <a:cxn ang="0">
+                  <a:pos x="connsiteX9" y="connsiteY9"/>
+                </a:cxn>
+                <a:cxn ang="0">
+                  <a:pos x="connsiteX10" y="connsiteY10"/>
+                </a:cxn>
+                <a:cxn ang="0">
+                  <a:pos x="connsiteX11" y="connsiteY11"/>
+                </a:cxn>
+                <a:cxn ang="0">
+                  <a:pos x="connsiteX12" y="connsiteY12"/>
+                </a:cxn>
+                <a:cxn ang="0">
+                  <a:pos x="connsiteX13" y="connsiteY13"/>
+                </a:cxn>
+                <a:cxn ang="0">
+                  <a:pos x="connsiteX14" y="connsiteY14"/>
+                </a:cxn>
+                <a:cxn ang="0">
+                  <a:pos x="connsiteX15" y="connsiteY15"/>
+                </a:cxn>
+              </a:cxnLst>
+              <a:rect l="l" t="t" r="r" b="b"/>
+              <a:pathLst>
+                <a:path w="864095" h="1011030">
+                  <a:moveTo>
+                    <a:pt x="296121" y="0"/>
+                  </a:moveTo>
+                  <a:lnTo>
+                    <a:pt x="714909" y="0"/>
+                  </a:lnTo>
+                  <a:lnTo>
+                    <a:pt x="864095" y="149186"/>
+                  </a:lnTo>
+                  <a:lnTo>
+                    <a:pt x="703511" y="309771"/>
+                  </a:lnTo>
+                  <a:lnTo>
+                    <a:pt x="620840" y="227100"/>
+                  </a:lnTo>
+                  <a:lnTo>
+                    <a:pt x="390190" y="227100"/>
+                  </a:lnTo>
+                  <a:lnTo>
+                    <a:pt x="227100" y="390190"/>
+                  </a:lnTo>
+                  <a:lnTo>
+                    <a:pt x="227100" y="620840"/>
+                  </a:lnTo>
+                  <a:lnTo>
+                    <a:pt x="390190" y="783930"/>
+                  </a:lnTo>
+                  <a:lnTo>
+                    <a:pt x="620840" y="783930"/>
+                  </a:lnTo>
+                  <a:lnTo>
+                    <a:pt x="703511" y="701260"/>
+                  </a:lnTo>
+                  <a:lnTo>
+                    <a:pt x="864095" y="861844"/>
+                  </a:lnTo>
+                  <a:lnTo>
+                    <a:pt x="714909" y="1011030"/>
+                  </a:lnTo>
+                  <a:lnTo>
+                    <a:pt x="296121" y="1011030"/>
+                  </a:lnTo>
+                  <a:lnTo>
+                    <a:pt x="0" y="714909"/>
+                  </a:lnTo>
+                  <a:lnTo>
+                    <a:pt x="0" y="296121"/>
+                  </a:lnTo>
+                  <a:close/>
+                </a:path>
+              </a:pathLst>
+            </a:custGeom>
+            <a:solidFill>
+              <a:schemeClr val="bg1"/>
+            </a:solidFill>
+            <a:ln>
+              <a:noFill/>
+            </a:ln>
+          </p:spPr>
+          <p:style>
+            <a:lnRef idx="2">
+              <a:schemeClr val="accent1">
+                <a:shade val="15000"/>
+              </a:schemeClr>
+            </a:lnRef>
+            <a:fillRef idx="1">
+              <a:schemeClr val="accent1"/>
+            </a:fillRef>
+            <a:effectRef idx="0">
+              <a:schemeClr val="accent1"/>
+            </a:effectRef>
+            <a:fontRef idx="minor">
+              <a:schemeClr val="lt1"/>
+            </a:fontRef>
+          </p:style>
+          <p:txBody>
+            <a:bodyPr wrap="square" rtlCol="0" anchor="ctr">
+              <a:noAutofit/>
+            </a:bodyPr>
+            <a:lstStyle/>
+            <a:p>
+              <a:pPr algn="ctr"/>
+              <a:endParaRPr lang="ko-KR" altLang="en-US"/>
+            </a:p>
+          </p:txBody>
+        </p:sp>
+      </p:grpSp>
+      <p:grpSp>
+        <p:nvGrpSpPr>
+          <p:cNvPr id="89" name="그룹 88">
+            <a:extLst>
+              <a:ext uri="{FF2B5EF4-FFF2-40B4-BE49-F238E27FC236}">
+                <a16:creationId xmlns:a16="http://schemas.microsoft.com/office/drawing/2014/main" id="{2FA9A67C-DBA7-3F9B-E247-720E22BE5697}"/>
+              </a:ext>
+            </a:extLst>
+          </p:cNvPr>
+          <p:cNvGrpSpPr/>
+          <p:nvPr/>
+        </p:nvGrpSpPr>
+        <p:grpSpPr>
+          <a:xfrm>
+            <a:off x="4059379" y="2339329"/>
+            <a:ext cx="1440000" cy="1440000"/>
+            <a:chOff x="4059379" y="2339329"/>
+            <a:chExt cx="1440000" cy="1440000"/>
+          </a:xfrm>
+        </p:grpSpPr>
+        <p:sp>
+          <p:nvSpPr>
+            <p:cNvPr id="26" name="팔각형 25">
+              <a:extLst>
+                <a:ext uri="{FF2B5EF4-FFF2-40B4-BE49-F238E27FC236}">
+                  <a16:creationId xmlns:a16="http://schemas.microsoft.com/office/drawing/2014/main" id="{4A7752BA-8AA1-044D-C33D-C6114273F827}"/>
+                </a:ext>
+              </a:extLst>
+            </p:cNvPr>
+            <p:cNvSpPr/>
+            <p:nvPr/>
+          </p:nvSpPr>
+          <p:spPr>
+            <a:xfrm>
+              <a:off x="4059379" y="2339329"/>
+              <a:ext cx="1440000" cy="1440000"/>
+            </a:xfrm>
+            <a:prstGeom prst="octagon">
+              <a:avLst/>
+            </a:prstGeom>
+            <a:solidFill>
+              <a:srgbClr val="00599C"/>
+            </a:solidFill>
+            <a:ln>
+              <a:noFill/>
+            </a:ln>
+          </p:spPr>
+          <p:style>
+            <a:lnRef idx="2">
+              <a:schemeClr val="accent1">
+                <a:shade val="15000"/>
+              </a:schemeClr>
+            </a:lnRef>
+            <a:fillRef idx="1">
+              <a:schemeClr val="accent1"/>
+            </a:fillRef>
+            <a:effectRef idx="0">
+              <a:schemeClr val="accent1"/>
+            </a:effectRef>
+            <a:fontRef idx="minor">
+              <a:schemeClr val="lt1"/>
+            </a:fontRef>
+          </p:style>
+          <p:txBody>
+            <a:bodyPr rtlCol="0" anchor="ctr"/>
+            <a:lstStyle/>
+            <a:p>
+              <a:pPr algn="ctr"/>
+              <a:endParaRPr lang="ko-KR" altLang="en-US"/>
+            </a:p>
+          </p:txBody>
+        </p:sp>
+        <p:sp>
+          <p:nvSpPr>
+            <p:cNvPr id="28" name="자유형: 도형 27">
+              <a:extLst>
+                <a:ext uri="{FF2B5EF4-FFF2-40B4-BE49-F238E27FC236}">
+                  <a16:creationId xmlns:a16="http://schemas.microsoft.com/office/drawing/2014/main" id="{86AB63A9-3691-CEA4-71ED-9B408339BDDA}"/>
+                </a:ext>
+              </a:extLst>
+            </p:cNvPr>
+            <p:cNvSpPr/>
+            <p:nvPr/>
+          </p:nvSpPr>
+          <p:spPr>
+            <a:xfrm rot="16200000">
+              <a:off x="4063320" y="2550210"/>
+              <a:ext cx="1229119" cy="1229119"/>
+            </a:xfrm>
+            <a:custGeom>
+              <a:avLst/>
+              <a:gdLst>
+                <a:gd name="connsiteX0" fmla="*/ 421762 w 1229119"/>
+                <a:gd name="connsiteY0" fmla="*/ 0 h 1229119"/>
+                <a:gd name="connsiteX1" fmla="*/ 1018238 w 1229119"/>
+                <a:gd name="connsiteY1" fmla="*/ 0 h 1229119"/>
+                <a:gd name="connsiteX2" fmla="*/ 1229119 w 1229119"/>
+                <a:gd name="connsiteY2" fmla="*/ 210881 h 1229119"/>
+                <a:gd name="connsiteX3" fmla="*/ 210881 w 1229119"/>
+                <a:gd name="connsiteY3" fmla="*/ 1229119 h 1229119"/>
+                <a:gd name="connsiteX4" fmla="*/ 0 w 1229119"/>
+                <a:gd name="connsiteY4" fmla="*/ 1018238 h 1229119"/>
+                <a:gd name="connsiteX5" fmla="*/ 0 w 1229119"/>
+                <a:gd name="connsiteY5" fmla="*/ 421762 h 1229119"/>
+              </a:gdLst>
+              <a:ahLst/>
+              <a:cxnLst>
+                <a:cxn ang="0">
+                  <a:pos x="connsiteX0" y="connsiteY0"/>
+                </a:cxn>
+                <a:cxn ang="0">
+                  <a:pos x="connsiteX1" y="connsiteY1"/>
+                </a:cxn>
+                <a:cxn ang="0">
+                  <a:pos x="connsiteX2" y="connsiteY2"/>
+                </a:cxn>
+                <a:cxn ang="0">
+                  <a:pos x="connsiteX3" y="connsiteY3"/>
+                </a:cxn>
+                <a:cxn ang="0">
+                  <a:pos x="connsiteX4" y="connsiteY4"/>
+                </a:cxn>
+                <a:cxn ang="0">
+                  <a:pos x="connsiteX5" y="connsiteY5"/>
+                </a:cxn>
+              </a:cxnLst>
+              <a:rect l="l" t="t" r="r" b="b"/>
+              <a:pathLst>
+                <a:path w="1229119" h="1229119">
+                  <a:moveTo>
+                    <a:pt x="421762" y="0"/>
+                  </a:moveTo>
+                  <a:lnTo>
+                    <a:pt x="1018238" y="0"/>
+                  </a:lnTo>
+                  <a:lnTo>
+                    <a:pt x="1229119" y="210881"/>
+                  </a:lnTo>
+                  <a:lnTo>
+                    <a:pt x="210881" y="1229119"/>
+                  </a:lnTo>
+                  <a:lnTo>
+                    <a:pt x="0" y="1018238"/>
+                  </a:lnTo>
+                  <a:lnTo>
+                    <a:pt x="0" y="421762"/>
+                  </a:lnTo>
+                  <a:close/>
+                </a:path>
+              </a:pathLst>
+            </a:custGeom>
+            <a:solidFill>
+              <a:srgbClr val="004482"/>
+            </a:solidFill>
+            <a:ln>
+              <a:noFill/>
+            </a:ln>
+          </p:spPr>
+          <p:style>
+            <a:lnRef idx="2">
+              <a:schemeClr val="accent1">
+                <a:shade val="15000"/>
+              </a:schemeClr>
+            </a:lnRef>
+            <a:fillRef idx="1">
+              <a:schemeClr val="accent1"/>
+            </a:fillRef>
+            <a:effectRef idx="0">
+              <a:schemeClr val="accent1"/>
+            </a:effectRef>
+            <a:fontRef idx="minor">
+              <a:schemeClr val="lt1"/>
+            </a:fontRef>
+          </p:style>
+          <p:txBody>
+            <a:bodyPr wrap="square" rtlCol="0" anchor="ctr">
+              <a:noAutofit/>
+            </a:bodyPr>
+            <a:lstStyle/>
+            <a:p>
+              <a:pPr algn="ctr"/>
+              <a:endParaRPr lang="ko-KR" altLang="en-US"/>
+            </a:p>
+          </p:txBody>
+        </p:sp>
+        <p:sp>
+          <p:nvSpPr>
+            <p:cNvPr id="29" name="자유형: 도형 28">
+              <a:extLst>
+                <a:ext uri="{FF2B5EF4-FFF2-40B4-BE49-F238E27FC236}">
+                  <a16:creationId xmlns:a16="http://schemas.microsoft.com/office/drawing/2014/main" id="{F4F306C5-DDB4-7024-533A-8C0649D09C7C}"/>
+                </a:ext>
+              </a:extLst>
+            </p:cNvPr>
+            <p:cNvSpPr/>
+            <p:nvPr/>
+          </p:nvSpPr>
+          <p:spPr>
+            <a:xfrm>
+              <a:off x="4059806" y="2340679"/>
+              <a:ext cx="1227600" cy="1229119"/>
+            </a:xfrm>
+            <a:custGeom>
+              <a:avLst/>
+              <a:gdLst>
+                <a:gd name="connsiteX0" fmla="*/ 421762 w 1229119"/>
+                <a:gd name="connsiteY0" fmla="*/ 0 h 1229119"/>
+                <a:gd name="connsiteX1" fmla="*/ 1018238 w 1229119"/>
+                <a:gd name="connsiteY1" fmla="*/ 0 h 1229119"/>
+                <a:gd name="connsiteX2" fmla="*/ 1229119 w 1229119"/>
+                <a:gd name="connsiteY2" fmla="*/ 210881 h 1229119"/>
+                <a:gd name="connsiteX3" fmla="*/ 210881 w 1229119"/>
+                <a:gd name="connsiteY3" fmla="*/ 1229119 h 1229119"/>
+                <a:gd name="connsiteX4" fmla="*/ 0 w 1229119"/>
+                <a:gd name="connsiteY4" fmla="*/ 1018238 h 1229119"/>
+                <a:gd name="connsiteX5" fmla="*/ 0 w 1229119"/>
+                <a:gd name="connsiteY5" fmla="*/ 421762 h 1229119"/>
+              </a:gdLst>
+              <a:ahLst/>
+              <a:cxnLst>
+                <a:cxn ang="0">
+                  <a:pos x="connsiteX0" y="connsiteY0"/>
+                </a:cxn>
+                <a:cxn ang="0">
+                  <a:pos x="connsiteX1" y="connsiteY1"/>
+                </a:cxn>
+                <a:cxn ang="0">
+                  <a:pos x="connsiteX2" y="connsiteY2"/>
+                </a:cxn>
+                <a:cxn ang="0">
+                  <a:pos x="connsiteX3" y="connsiteY3"/>
+                </a:cxn>
+                <a:cxn ang="0">
+                  <a:pos x="connsiteX4" y="connsiteY4"/>
+                </a:cxn>
+                <a:cxn ang="0">
+                  <a:pos x="connsiteX5" y="connsiteY5"/>
+                </a:cxn>
+              </a:cxnLst>
+              <a:rect l="l" t="t" r="r" b="b"/>
+              <a:pathLst>
+                <a:path w="1229119" h="1229119">
+                  <a:moveTo>
+                    <a:pt x="421762" y="0"/>
+                  </a:moveTo>
+                  <a:lnTo>
+                    <a:pt x="1018238" y="0"/>
+                  </a:lnTo>
+                  <a:lnTo>
+                    <a:pt x="1229119" y="210881"/>
+                  </a:lnTo>
+                  <a:lnTo>
+                    <a:pt x="210881" y="1229119"/>
+                  </a:lnTo>
+                  <a:lnTo>
+                    <a:pt x="0" y="1018238"/>
+                  </a:lnTo>
+                  <a:lnTo>
+                    <a:pt x="0" y="421762"/>
+                  </a:lnTo>
+                  <a:close/>
+                </a:path>
+              </a:pathLst>
+            </a:custGeom>
+            <a:solidFill>
+              <a:srgbClr val="659AD2"/>
+            </a:solidFill>
+            <a:ln>
+              <a:noFill/>
+            </a:ln>
+          </p:spPr>
+          <p:style>
+            <a:lnRef idx="2">
+              <a:schemeClr val="accent1">
+                <a:shade val="15000"/>
+              </a:schemeClr>
+            </a:lnRef>
+            <a:fillRef idx="1">
+              <a:schemeClr val="accent1"/>
+            </a:fillRef>
+            <a:effectRef idx="0">
+              <a:schemeClr val="accent1"/>
+            </a:effectRef>
+            <a:fontRef idx="minor">
+              <a:schemeClr val="lt1"/>
+            </a:fontRef>
+          </p:style>
+          <p:txBody>
+            <a:bodyPr wrap="square" rtlCol="0" anchor="ctr">
+              <a:noAutofit/>
+            </a:bodyPr>
+            <a:lstStyle/>
+            <a:p>
+              <a:pPr algn="ctr"/>
+              <a:endParaRPr lang="ko-KR" altLang="en-US"/>
+            </a:p>
+          </p:txBody>
+        </p:sp>
+        <p:sp>
+          <p:nvSpPr>
+            <p:cNvPr id="30" name="자유형: 도형 29">
+              <a:extLst>
+                <a:ext uri="{FF2B5EF4-FFF2-40B4-BE49-F238E27FC236}">
+                  <a16:creationId xmlns:a16="http://schemas.microsoft.com/office/drawing/2014/main" id="{778E6BE7-744D-CA34-C03C-A3E9EF903E51}"/>
+                </a:ext>
+              </a:extLst>
+            </p:cNvPr>
+            <p:cNvSpPr/>
+            <p:nvPr/>
+          </p:nvSpPr>
+          <p:spPr>
+            <a:xfrm>
+              <a:off x="4276377" y="2550209"/>
+              <a:ext cx="864095" cy="1011030"/>
+            </a:xfrm>
+            <a:custGeom>
+              <a:avLst/>
+              <a:gdLst>
+                <a:gd name="connsiteX0" fmla="*/ 296121 w 864095"/>
+                <a:gd name="connsiteY0" fmla="*/ 0 h 1011030"/>
+                <a:gd name="connsiteX1" fmla="*/ 714909 w 864095"/>
+                <a:gd name="connsiteY1" fmla="*/ 0 h 1011030"/>
+                <a:gd name="connsiteX2" fmla="*/ 864095 w 864095"/>
+                <a:gd name="connsiteY2" fmla="*/ 149186 h 1011030"/>
+                <a:gd name="connsiteX3" fmla="*/ 703511 w 864095"/>
+                <a:gd name="connsiteY3" fmla="*/ 309771 h 1011030"/>
+                <a:gd name="connsiteX4" fmla="*/ 620840 w 864095"/>
+                <a:gd name="connsiteY4" fmla="*/ 227100 h 1011030"/>
+                <a:gd name="connsiteX5" fmla="*/ 390190 w 864095"/>
+                <a:gd name="connsiteY5" fmla="*/ 227100 h 1011030"/>
+                <a:gd name="connsiteX6" fmla="*/ 227100 w 864095"/>
+                <a:gd name="connsiteY6" fmla="*/ 390190 h 1011030"/>
+                <a:gd name="connsiteX7" fmla="*/ 227100 w 864095"/>
+                <a:gd name="connsiteY7" fmla="*/ 620840 h 1011030"/>
+                <a:gd name="connsiteX8" fmla="*/ 390190 w 864095"/>
+                <a:gd name="connsiteY8" fmla="*/ 783930 h 1011030"/>
+                <a:gd name="connsiteX9" fmla="*/ 620840 w 864095"/>
+                <a:gd name="connsiteY9" fmla="*/ 783930 h 1011030"/>
+                <a:gd name="connsiteX10" fmla="*/ 703511 w 864095"/>
+                <a:gd name="connsiteY10" fmla="*/ 701260 h 1011030"/>
+                <a:gd name="connsiteX11" fmla="*/ 864095 w 864095"/>
+                <a:gd name="connsiteY11" fmla="*/ 861844 h 1011030"/>
+                <a:gd name="connsiteX12" fmla="*/ 714909 w 864095"/>
+                <a:gd name="connsiteY12" fmla="*/ 1011030 h 1011030"/>
+                <a:gd name="connsiteX13" fmla="*/ 296121 w 864095"/>
+                <a:gd name="connsiteY13" fmla="*/ 1011030 h 1011030"/>
+                <a:gd name="connsiteX14" fmla="*/ 0 w 864095"/>
+                <a:gd name="connsiteY14" fmla="*/ 714909 h 1011030"/>
+                <a:gd name="connsiteX15" fmla="*/ 0 w 864095"/>
+                <a:gd name="connsiteY15" fmla="*/ 296121 h 1011030"/>
+              </a:gdLst>
+              <a:ahLst/>
+              <a:cxnLst>
+                <a:cxn ang="0">
+                  <a:pos x="connsiteX0" y="connsiteY0"/>
+                </a:cxn>
+                <a:cxn ang="0">
+                  <a:pos x="connsiteX1" y="connsiteY1"/>
+                </a:cxn>
+                <a:cxn ang="0">
+                  <a:pos x="connsiteX2" y="connsiteY2"/>
+                </a:cxn>
+                <a:cxn ang="0">
+                  <a:pos x="connsiteX3" y="connsiteY3"/>
+                </a:cxn>
+                <a:cxn ang="0">
+                  <a:pos x="connsiteX4" y="connsiteY4"/>
+                </a:cxn>
+                <a:cxn ang="0">
+                  <a:pos x="connsiteX5" y="connsiteY5"/>
+                </a:cxn>
+                <a:cxn ang="0">
+                  <a:pos x="connsiteX6" y="connsiteY6"/>
+                </a:cxn>
+                <a:cxn ang="0">
+                  <a:pos x="connsiteX7" y="connsiteY7"/>
+                </a:cxn>
+                <a:cxn ang="0">
+                  <a:pos x="connsiteX8" y="connsiteY8"/>
+                </a:cxn>
+                <a:cxn ang="0">
+                  <a:pos x="connsiteX9" y="connsiteY9"/>
+                </a:cxn>
+                <a:cxn ang="0">
+                  <a:pos x="connsiteX10" y="connsiteY10"/>
+                </a:cxn>
+                <a:cxn ang="0">
+                  <a:pos x="connsiteX11" y="connsiteY11"/>
+                </a:cxn>
+                <a:cxn ang="0">
+                  <a:pos x="connsiteX12" y="connsiteY12"/>
+                </a:cxn>
+                <a:cxn ang="0">
+                  <a:pos x="connsiteX13" y="connsiteY13"/>
+                </a:cxn>
+                <a:cxn ang="0">
+                  <a:pos x="connsiteX14" y="connsiteY14"/>
+                </a:cxn>
+                <a:cxn ang="0">
+                  <a:pos x="connsiteX15" y="connsiteY15"/>
+                </a:cxn>
+              </a:cxnLst>
+              <a:rect l="l" t="t" r="r" b="b"/>
+              <a:pathLst>
+                <a:path w="864095" h="1011030">
+                  <a:moveTo>
+                    <a:pt x="296121" y="0"/>
+                  </a:moveTo>
+                  <a:lnTo>
+                    <a:pt x="714909" y="0"/>
+                  </a:lnTo>
+                  <a:lnTo>
+                    <a:pt x="864095" y="149186"/>
+                  </a:lnTo>
+                  <a:lnTo>
+                    <a:pt x="703511" y="309771"/>
+                  </a:lnTo>
+                  <a:lnTo>
+                    <a:pt x="620840" y="227100"/>
+                  </a:lnTo>
+                  <a:lnTo>
+                    <a:pt x="390190" y="227100"/>
+                  </a:lnTo>
+                  <a:lnTo>
+                    <a:pt x="227100" y="390190"/>
+                  </a:lnTo>
+                  <a:lnTo>
+                    <a:pt x="227100" y="620840"/>
+                  </a:lnTo>
+                  <a:lnTo>
+                    <a:pt x="390190" y="783930"/>
+                  </a:lnTo>
+                  <a:lnTo>
+                    <a:pt x="620840" y="783930"/>
+                  </a:lnTo>
+                  <a:lnTo>
+                    <a:pt x="703511" y="701260"/>
+                  </a:lnTo>
+                  <a:lnTo>
+                    <a:pt x="864095" y="861844"/>
+                  </a:lnTo>
+                  <a:lnTo>
+                    <a:pt x="714909" y="1011030"/>
+                  </a:lnTo>
+                  <a:lnTo>
+                    <a:pt x="296121" y="1011030"/>
+                  </a:lnTo>
+                  <a:lnTo>
+                    <a:pt x="0" y="714909"/>
+                  </a:lnTo>
+                  <a:lnTo>
+                    <a:pt x="0" y="296121"/>
+                  </a:lnTo>
+                  <a:close/>
+                </a:path>
+              </a:pathLst>
+            </a:custGeom>
+            <a:solidFill>
+              <a:schemeClr val="bg1"/>
+            </a:solidFill>
+            <a:ln>
+              <a:noFill/>
+            </a:ln>
+          </p:spPr>
+          <p:style>
+            <a:lnRef idx="2">
+              <a:schemeClr val="accent1">
+                <a:shade val="15000"/>
+              </a:schemeClr>
+            </a:lnRef>
+            <a:fillRef idx="1">
+              <a:schemeClr val="accent1"/>
+            </a:fillRef>
+            <a:effectRef idx="0">
+              <a:schemeClr val="accent1"/>
+            </a:effectRef>
+            <a:fontRef idx="minor">
+              <a:schemeClr val="lt1"/>
+            </a:fontRef>
+          </p:style>
+          <p:txBody>
+            <a:bodyPr wrap="square" rtlCol="0" anchor="ctr">
+              <a:noAutofit/>
+            </a:bodyPr>
+            <a:lstStyle/>
+            <a:p>
+              <a:pPr algn="ctr"/>
+              <a:endParaRPr lang="ko-KR" altLang="en-US"/>
+            </a:p>
+          </p:txBody>
+        </p:sp>
+        <p:sp>
+          <p:nvSpPr>
+            <p:cNvPr id="48" name="팔각형 47">
+              <a:extLst>
+                <a:ext uri="{FF2B5EF4-FFF2-40B4-BE49-F238E27FC236}">
+                  <a16:creationId xmlns:a16="http://schemas.microsoft.com/office/drawing/2014/main" id="{3A6118A1-A679-41DE-A335-4F892719DC11}"/>
+                </a:ext>
+              </a:extLst>
+            </p:cNvPr>
+            <p:cNvSpPr/>
+            <p:nvPr/>
+          </p:nvSpPr>
+          <p:spPr>
+            <a:xfrm>
+              <a:off x="5072227" y="2949192"/>
+              <a:ext cx="70363" cy="213063"/>
+            </a:xfrm>
+            <a:prstGeom prst="octagon">
+              <a:avLst/>
+            </a:prstGeom>
+            <a:solidFill>
+              <a:schemeClr val="bg1"/>
+            </a:solidFill>
+            <a:ln>
+              <a:noFill/>
+            </a:ln>
+          </p:spPr>
+          <p:style>
+            <a:lnRef idx="2">
+              <a:schemeClr val="accent1">
+                <a:shade val="15000"/>
+              </a:schemeClr>
+            </a:lnRef>
+            <a:fillRef idx="1">
+              <a:schemeClr val="accent1"/>
+            </a:fillRef>
+            <a:effectRef idx="0">
+              <a:schemeClr val="accent1"/>
+            </a:effectRef>
+            <a:fontRef idx="minor">
+              <a:schemeClr val="lt1"/>
+            </a:fontRef>
+          </p:style>
+          <p:txBody>
+            <a:bodyPr wrap="square" rtlCol="0" anchor="ctr">
+              <a:noAutofit/>
+            </a:bodyPr>
+            <a:lstStyle/>
+            <a:p>
+              <a:pPr algn="ctr"/>
+              <a:endParaRPr lang="ko-KR" altLang="en-US"/>
+            </a:p>
+          </p:txBody>
+        </p:sp>
+        <p:sp>
+          <p:nvSpPr>
+            <p:cNvPr id="81" name="팔각형 80">
+              <a:extLst>
+                <a:ext uri="{FF2B5EF4-FFF2-40B4-BE49-F238E27FC236}">
+                  <a16:creationId xmlns:a16="http://schemas.microsoft.com/office/drawing/2014/main" id="{E0EA975C-E8F5-B4E7-01C7-0EFFA7A4B739}"/>
+                </a:ext>
+              </a:extLst>
+            </p:cNvPr>
+            <p:cNvSpPr/>
+            <p:nvPr/>
+          </p:nvSpPr>
+          <p:spPr>
+            <a:xfrm rot="5400000">
+              <a:off x="5072226" y="2949191"/>
+              <a:ext cx="70363" cy="213063"/>
+            </a:xfrm>
+            <a:prstGeom prst="octagon">
+              <a:avLst/>
+            </a:prstGeom>
+            <a:solidFill>
+              <a:schemeClr val="bg1"/>
+            </a:solidFill>
+            <a:ln>
+              <a:noFill/>
+            </a:ln>
+          </p:spPr>
+          <p:style>
+            <a:lnRef idx="2">
+              <a:schemeClr val="accent1">
+                <a:shade val="15000"/>
+              </a:schemeClr>
+            </a:lnRef>
+            <a:fillRef idx="1">
+              <a:schemeClr val="accent1"/>
+            </a:fillRef>
+            <a:effectRef idx="0">
+              <a:schemeClr val="accent1"/>
+            </a:effectRef>
+            <a:fontRef idx="minor">
+              <a:schemeClr val="lt1"/>
+            </a:fontRef>
+          </p:style>
+          <p:txBody>
+            <a:bodyPr wrap="square" rtlCol="0" anchor="ctr">
+              <a:noAutofit/>
+            </a:bodyPr>
+            <a:lstStyle/>
+            <a:p>
+              <a:pPr algn="ctr"/>
+              <a:endParaRPr lang="ko-KR" altLang="en-US"/>
+            </a:p>
+          </p:txBody>
+        </p:sp>
+        <p:sp>
+          <p:nvSpPr>
+            <p:cNvPr id="83" name="팔각형 82">
+              <a:extLst>
+                <a:ext uri="{FF2B5EF4-FFF2-40B4-BE49-F238E27FC236}">
+                  <a16:creationId xmlns:a16="http://schemas.microsoft.com/office/drawing/2014/main" id="{10ED323D-3C2E-45B4-FB2B-B47CE8A551EF}"/>
+                </a:ext>
+              </a:extLst>
+            </p:cNvPr>
+            <p:cNvSpPr/>
+            <p:nvPr/>
+          </p:nvSpPr>
+          <p:spPr>
+            <a:xfrm>
+              <a:off x="5324603" y="2949192"/>
+              <a:ext cx="70363" cy="213063"/>
+            </a:xfrm>
+            <a:prstGeom prst="octagon">
+              <a:avLst/>
+            </a:prstGeom>
+            <a:solidFill>
+              <a:schemeClr val="bg1"/>
+            </a:solidFill>
+            <a:ln>
+              <a:noFill/>
+            </a:ln>
+          </p:spPr>
+          <p:style>
+            <a:lnRef idx="2">
+              <a:schemeClr val="accent1">
+                <a:shade val="15000"/>
+              </a:schemeClr>
+            </a:lnRef>
+            <a:fillRef idx="1">
+              <a:schemeClr val="accent1"/>
+            </a:fillRef>
+            <a:effectRef idx="0">
+              <a:schemeClr val="accent1"/>
+            </a:effectRef>
+            <a:fontRef idx="minor">
+              <a:schemeClr val="lt1"/>
+            </a:fontRef>
+          </p:style>
+          <p:txBody>
+            <a:bodyPr wrap="square" rtlCol="0" anchor="ctr">
+              <a:noAutofit/>
+            </a:bodyPr>
+            <a:lstStyle/>
+            <a:p>
+              <a:pPr algn="ctr"/>
+              <a:endParaRPr lang="ko-KR" altLang="en-US"/>
+            </a:p>
+          </p:txBody>
+        </p:sp>
+        <p:sp>
+          <p:nvSpPr>
+            <p:cNvPr id="88" name="팔각형 87">
+              <a:extLst>
+                <a:ext uri="{FF2B5EF4-FFF2-40B4-BE49-F238E27FC236}">
+                  <a16:creationId xmlns:a16="http://schemas.microsoft.com/office/drawing/2014/main" id="{4CC4A3CD-F096-988E-A2B5-19FE656469D7}"/>
+                </a:ext>
+              </a:extLst>
+            </p:cNvPr>
+            <p:cNvSpPr/>
+            <p:nvPr/>
+          </p:nvSpPr>
+          <p:spPr>
+            <a:xfrm rot="5400000">
+              <a:off x="5324602" y="2949191"/>
+              <a:ext cx="70363" cy="213063"/>
+            </a:xfrm>
+            <a:prstGeom prst="octagon">
+              <a:avLst/>
+            </a:prstGeom>
+            <a:solidFill>
+              <a:schemeClr val="bg1"/>
+            </a:solidFill>
+            <a:ln>
+              <a:noFill/>
+            </a:ln>
+          </p:spPr>
+          <p:style>
+            <a:lnRef idx="2">
+              <a:schemeClr val="accent1">
+                <a:shade val="15000"/>
+              </a:schemeClr>
+            </a:lnRef>
+            <a:fillRef idx="1">
+              <a:schemeClr val="accent1"/>
+            </a:fillRef>
+            <a:effectRef idx="0">
+              <a:schemeClr val="accent1"/>
+            </a:effectRef>
+            <a:fontRef idx="minor">
+              <a:schemeClr val="lt1"/>
+            </a:fontRef>
+          </p:style>
+          <p:txBody>
+            <a:bodyPr wrap="square" rtlCol="0" anchor="ctr">
+              <a:noAutofit/>
+            </a:bodyPr>
+            <a:lstStyle/>
+            <a:p>
+              <a:pPr algn="ctr"/>
+              <a:endParaRPr lang="ko-KR" altLang="en-US"/>
+            </a:p>
+          </p:txBody>
+        </p:sp>
+      </p:grpSp>
     </p:spTree>
     <p:extLst>
       <p:ext uri="{BB962C8B-B14F-4D97-AF65-F5344CB8AC3E}">

</xml_diff>

<commit_message>
Added swift logo, and fixed Python logo
</commit_message>
<xml_diff>
--- a/tepk2924_Custon_Icon.pptx
+++ b/tepk2924_Custon_Icon.pptx
@@ -3965,58 +3965,6 @@
           </a:p>
         </p:txBody>
       </p:sp>
-      <p:sp>
-        <p:nvSpPr>
-          <p:cNvPr id="32" name="팔각형 31">
-            <a:extLst>
-              <a:ext uri="{FF2B5EF4-FFF2-40B4-BE49-F238E27FC236}">
-                <a16:creationId xmlns:a16="http://schemas.microsoft.com/office/drawing/2014/main" id="{AB25C666-7978-C138-8710-C9631D68249F}"/>
-              </a:ext>
-            </a:extLst>
-          </p:cNvPr>
-          <p:cNvSpPr/>
-          <p:nvPr/>
-        </p:nvSpPr>
-        <p:spPr>
-          <a:xfrm>
-            <a:off x="8205251" y="4013016"/>
-            <a:ext cx="1044000" cy="1044000"/>
-          </a:xfrm>
-          <a:prstGeom prst="octagon">
-            <a:avLst/>
-          </a:prstGeom>
-          <a:solidFill>
-            <a:srgbClr val="0D39AD"/>
-          </a:solidFill>
-          <a:ln>
-            <a:noFill/>
-          </a:ln>
-        </p:spPr>
-        <p:style>
-          <a:lnRef idx="2">
-            <a:schemeClr val="accent1">
-              <a:shade val="15000"/>
-            </a:schemeClr>
-          </a:lnRef>
-          <a:fillRef idx="1">
-            <a:schemeClr val="accent1"/>
-          </a:fillRef>
-          <a:effectRef idx="0">
-            <a:schemeClr val="accent1"/>
-          </a:effectRef>
-          <a:fontRef idx="minor">
-            <a:schemeClr val="lt1"/>
-          </a:fontRef>
-        </p:style>
-        <p:txBody>
-          <a:bodyPr rtlCol="0" anchor="ctr"/>
-          <a:lstStyle/>
-          <a:p>
-            <a:pPr algn="ctr"/>
-            <a:endParaRPr lang="ko-KR" altLang="en-US"/>
-          </a:p>
-        </p:txBody>
-      </p:sp>
     </p:spTree>
     <p:extLst>
       <p:ext uri="{BB962C8B-B14F-4D97-AF65-F5344CB8AC3E}">
@@ -26392,10 +26340,10 @@
       </p:grpSp>
       <p:grpSp>
         <p:nvGrpSpPr>
-          <p:cNvPr id="87" name="그룹 86">
+          <p:cNvPr id="97" name="그룹 96">
             <a:extLst>
               <a:ext uri="{FF2B5EF4-FFF2-40B4-BE49-F238E27FC236}">
-                <a16:creationId xmlns:a16="http://schemas.microsoft.com/office/drawing/2014/main" id="{B1C12F29-E49A-10E7-B16D-8EDE0D3CFA8F}"/>
+                <a16:creationId xmlns:a16="http://schemas.microsoft.com/office/drawing/2014/main" id="{B983D085-F45C-4546-A48C-CEC2E55665BA}"/>
               </a:ext>
             </a:extLst>
           </p:cNvPr>
@@ -26406,16 +26354,16 @@
           <a:xfrm>
             <a:off x="9690951" y="242804"/>
             <a:ext cx="1440000" cy="1440000"/>
-            <a:chOff x="3689564" y="3438526"/>
+            <a:chOff x="9690951" y="242804"/>
             <a:chExt cx="1440000" cy="1440000"/>
           </a:xfrm>
         </p:grpSpPr>
         <p:sp>
           <p:nvSpPr>
-            <p:cNvPr id="85" name="자유형: 도형 84">
+            <p:cNvPr id="95" name="자유형: 도형 94">
               <a:extLst>
                 <a:ext uri="{FF2B5EF4-FFF2-40B4-BE49-F238E27FC236}">
-                  <a16:creationId xmlns:a16="http://schemas.microsoft.com/office/drawing/2014/main" id="{A1C7C9CC-0868-2164-3FEF-FD8885A915A8}"/>
+                  <a16:creationId xmlns:a16="http://schemas.microsoft.com/office/drawing/2014/main" id="{B1A113CD-1F7C-3E9B-EB16-F89EAF4348FE}"/>
                 </a:ext>
               </a:extLst>
             </p:cNvPr>
@@ -26424,7 +26372,7 @@
           </p:nvSpPr>
           <p:spPr>
             <a:xfrm>
-              <a:off x="3689564" y="3438526"/>
+              <a:off x="9690951" y="242804"/>
               <a:ext cx="1063145" cy="1077191"/>
             </a:xfrm>
             <a:custGeom>
@@ -26491,9 +26439,21 @@
                 <a:gd name="connsiteX29" fmla="*/ 379145 w 1063145"/>
                 <a:gd name="connsiteY29" fmla="*/ 362809 h 1077191"/>
                 <a:gd name="connsiteX30" fmla="*/ 379145 w 1063145"/>
-                <a:gd name="connsiteY30" fmla="*/ 100009 h 1077191"/>
-                <a:gd name="connsiteX31" fmla="*/ 379148 w 1063145"/>
-                <a:gd name="connsiteY31" fmla="*/ 100012 h 1077191"/>
+                <a:gd name="connsiteY30" fmla="*/ 362808 h 1077191"/>
+                <a:gd name="connsiteX31" fmla="*/ 710582 w 1063145"/>
+                <a:gd name="connsiteY31" fmla="*/ 362808 h 1077191"/>
+                <a:gd name="connsiteX32" fmla="*/ 724637 w 1063145"/>
+                <a:gd name="connsiteY32" fmla="*/ 348753 h 1077191"/>
+                <a:gd name="connsiteX33" fmla="*/ 724637 w 1063145"/>
+                <a:gd name="connsiteY33" fmla="*/ 328876 h 1077191"/>
+                <a:gd name="connsiteX34" fmla="*/ 710582 w 1063145"/>
+                <a:gd name="connsiteY34" fmla="*/ 314821 h 1077191"/>
+                <a:gd name="connsiteX35" fmla="*/ 379145 w 1063145"/>
+                <a:gd name="connsiteY35" fmla="*/ 314821 h 1077191"/>
+                <a:gd name="connsiteX36" fmla="*/ 379145 w 1063145"/>
+                <a:gd name="connsiteY36" fmla="*/ 100009 h 1077191"/>
+                <a:gd name="connsiteX37" fmla="*/ 379148 w 1063145"/>
+                <a:gd name="connsiteY37" fmla="*/ 100012 h 1077191"/>
               </a:gdLst>
               <a:ahLst/>
               <a:cxnLst>
@@ -26592,6 +26552,24 @@
                 </a:cxn>
                 <a:cxn ang="0">
                   <a:pos x="connsiteX31" y="connsiteY31"/>
+                </a:cxn>
+                <a:cxn ang="0">
+                  <a:pos x="connsiteX32" y="connsiteY32"/>
+                </a:cxn>
+                <a:cxn ang="0">
+                  <a:pos x="connsiteX33" y="connsiteY33"/>
+                </a:cxn>
+                <a:cxn ang="0">
+                  <a:pos x="connsiteX34" y="connsiteY34"/>
+                </a:cxn>
+                <a:cxn ang="0">
+                  <a:pos x="connsiteX35" y="connsiteY35"/>
+                </a:cxn>
+                <a:cxn ang="0">
+                  <a:pos x="connsiteX36" y="connsiteY36"/>
+                </a:cxn>
+                <a:cxn ang="0">
+                  <a:pos x="connsiteX37" y="connsiteY37"/>
                 </a:cxn>
               </a:cxnLst>
               <a:rect l="l" t="t" r="r" b="b"/>
@@ -26687,6 +26665,24 @@
                   </a:lnTo>
                   <a:lnTo>
                     <a:pt x="379145" y="362809"/>
+                  </a:lnTo>
+                  <a:lnTo>
+                    <a:pt x="379145" y="362808"/>
+                  </a:lnTo>
+                  <a:lnTo>
+                    <a:pt x="710582" y="362808"/>
+                  </a:lnTo>
+                  <a:lnTo>
+                    <a:pt x="724637" y="348753"/>
+                  </a:lnTo>
+                  <a:lnTo>
+                    <a:pt x="724637" y="328876"/>
+                  </a:lnTo>
+                  <a:lnTo>
+                    <a:pt x="710582" y="314821"/>
+                  </a:lnTo>
+                  <a:lnTo>
+                    <a:pt x="379145" y="314821"/>
                   </a:lnTo>
                   <a:lnTo>
                     <a:pt x="379145" y="100009"/>
@@ -26734,10 +26730,10 @@
         </p:sp>
         <p:sp>
           <p:nvSpPr>
-            <p:cNvPr id="86" name="자유형: 도형 85">
+            <p:cNvPr id="96" name="자유형: 도형 95">
               <a:extLst>
                 <a:ext uri="{FF2B5EF4-FFF2-40B4-BE49-F238E27FC236}">
-                  <a16:creationId xmlns:a16="http://schemas.microsoft.com/office/drawing/2014/main" id="{18E11F12-5C3C-C020-BE36-802D8D11ECC5}"/>
+                  <a16:creationId xmlns:a16="http://schemas.microsoft.com/office/drawing/2014/main" id="{83FE5DD8-363A-2F74-CC7D-8DF6EA4574A6}"/>
                 </a:ext>
               </a:extLst>
             </p:cNvPr>
@@ -26746,7 +26742,7 @@
           </p:nvSpPr>
           <p:spPr>
             <a:xfrm rot="10800000">
-              <a:off x="4066419" y="3801335"/>
+              <a:off x="10067806" y="605613"/>
               <a:ext cx="1063145" cy="1077191"/>
             </a:xfrm>
             <a:custGeom>
@@ -26787,27 +26783,39 @@
                 <a:gd name="connsiteX16" fmla="*/ 379145 w 1063145"/>
                 <a:gd name="connsiteY16" fmla="*/ 362809 h 1077191"/>
                 <a:gd name="connsiteX17" fmla="*/ 379145 w 1063145"/>
-                <a:gd name="connsiteY17" fmla="*/ 100009 h 1077191"/>
-                <a:gd name="connsiteX18" fmla="*/ 379148 w 1063145"/>
-                <a:gd name="connsiteY18" fmla="*/ 100012 h 1077191"/>
-                <a:gd name="connsiteX19" fmla="*/ 479160 w 1063145"/>
-                <a:gd name="connsiteY19" fmla="*/ 0 h 1077191"/>
-                <a:gd name="connsiteX20" fmla="*/ 963133 w 1063145"/>
-                <a:gd name="connsiteY20" fmla="*/ 0 h 1077191"/>
-                <a:gd name="connsiteX21" fmla="*/ 1063145 w 1063145"/>
-                <a:gd name="connsiteY21" fmla="*/ 100012 h 1077191"/>
-                <a:gd name="connsiteX22" fmla="*/ 1063145 w 1063145"/>
-                <a:gd name="connsiteY22" fmla="*/ 615226 h 1077191"/>
-                <a:gd name="connsiteX23" fmla="*/ 977058 w 1063145"/>
-                <a:gd name="connsiteY23" fmla="*/ 701313 h 1077191"/>
-                <a:gd name="connsiteX24" fmla="*/ 434553 w 1063145"/>
-                <a:gd name="connsiteY24" fmla="*/ 701313 h 1077191"/>
-                <a:gd name="connsiteX25" fmla="*/ 419661 w 1063145"/>
-                <a:gd name="connsiteY25" fmla="*/ 715713 h 1077191"/>
-                <a:gd name="connsiteX26" fmla="*/ 422113 w 1063145"/>
-                <a:gd name="connsiteY26" fmla="*/ 715713 h 1077191"/>
-                <a:gd name="connsiteX27" fmla="*/ 329585 w 1063145"/>
-                <a:gd name="connsiteY27" fmla="*/ 808241 h 1077191"/>
+                <a:gd name="connsiteY17" fmla="*/ 362808 h 1077191"/>
+                <a:gd name="connsiteX18" fmla="*/ 710582 w 1063145"/>
+                <a:gd name="connsiteY18" fmla="*/ 362808 h 1077191"/>
+                <a:gd name="connsiteX19" fmla="*/ 724637 w 1063145"/>
+                <a:gd name="connsiteY19" fmla="*/ 348753 h 1077191"/>
+                <a:gd name="connsiteX20" fmla="*/ 724637 w 1063145"/>
+                <a:gd name="connsiteY20" fmla="*/ 328876 h 1077191"/>
+                <a:gd name="connsiteX21" fmla="*/ 710582 w 1063145"/>
+                <a:gd name="connsiteY21" fmla="*/ 314821 h 1077191"/>
+                <a:gd name="connsiteX22" fmla="*/ 379145 w 1063145"/>
+                <a:gd name="connsiteY22" fmla="*/ 314821 h 1077191"/>
+                <a:gd name="connsiteX23" fmla="*/ 379145 w 1063145"/>
+                <a:gd name="connsiteY23" fmla="*/ 100009 h 1077191"/>
+                <a:gd name="connsiteX24" fmla="*/ 379148 w 1063145"/>
+                <a:gd name="connsiteY24" fmla="*/ 100012 h 1077191"/>
+                <a:gd name="connsiteX25" fmla="*/ 479160 w 1063145"/>
+                <a:gd name="connsiteY25" fmla="*/ 0 h 1077191"/>
+                <a:gd name="connsiteX26" fmla="*/ 963133 w 1063145"/>
+                <a:gd name="connsiteY26" fmla="*/ 0 h 1077191"/>
+                <a:gd name="connsiteX27" fmla="*/ 1063145 w 1063145"/>
+                <a:gd name="connsiteY27" fmla="*/ 100012 h 1077191"/>
+                <a:gd name="connsiteX28" fmla="*/ 1063145 w 1063145"/>
+                <a:gd name="connsiteY28" fmla="*/ 615226 h 1077191"/>
+                <a:gd name="connsiteX29" fmla="*/ 977058 w 1063145"/>
+                <a:gd name="connsiteY29" fmla="*/ 701313 h 1077191"/>
+                <a:gd name="connsiteX30" fmla="*/ 434553 w 1063145"/>
+                <a:gd name="connsiteY30" fmla="*/ 701313 h 1077191"/>
+                <a:gd name="connsiteX31" fmla="*/ 419661 w 1063145"/>
+                <a:gd name="connsiteY31" fmla="*/ 715713 h 1077191"/>
+                <a:gd name="connsiteX32" fmla="*/ 422113 w 1063145"/>
+                <a:gd name="connsiteY32" fmla="*/ 715713 h 1077191"/>
+                <a:gd name="connsiteX33" fmla="*/ 329585 w 1063145"/>
+                <a:gd name="connsiteY33" fmla="*/ 808241 h 1077191"/>
               </a:gdLst>
               <a:ahLst/>
               <a:cxnLst>
@@ -26894,6 +26902,24 @@
                 </a:cxn>
                 <a:cxn ang="0">
                   <a:pos x="connsiteX27" y="connsiteY27"/>
+                </a:cxn>
+                <a:cxn ang="0">
+                  <a:pos x="connsiteX28" y="connsiteY28"/>
+                </a:cxn>
+                <a:cxn ang="0">
+                  <a:pos x="connsiteX29" y="connsiteY29"/>
+                </a:cxn>
+                <a:cxn ang="0">
+                  <a:pos x="connsiteX30" y="connsiteY30"/>
+                </a:cxn>
+                <a:cxn ang="0">
+                  <a:pos x="connsiteX31" y="connsiteY31"/>
+                </a:cxn>
+                <a:cxn ang="0">
+                  <a:pos x="connsiteX32" y="connsiteY32"/>
+                </a:cxn>
+                <a:cxn ang="0">
+                  <a:pos x="connsiteX33" y="connsiteY33"/>
                 </a:cxn>
               </a:cxnLst>
               <a:rect l="l" t="t" r="r" b="b"/>
@@ -26950,6 +26976,24 @@
                   </a:lnTo>
                   <a:lnTo>
                     <a:pt x="379145" y="362809"/>
+                  </a:lnTo>
+                  <a:lnTo>
+                    <a:pt x="379145" y="362808"/>
+                  </a:lnTo>
+                  <a:lnTo>
+                    <a:pt x="710582" y="362808"/>
+                  </a:lnTo>
+                  <a:lnTo>
+                    <a:pt x="724637" y="348753"/>
+                  </a:lnTo>
+                  <a:lnTo>
+                    <a:pt x="724637" y="328876"/>
+                  </a:lnTo>
+                  <a:lnTo>
+                    <a:pt x="710582" y="314821"/>
+                  </a:lnTo>
+                  <a:lnTo>
+                    <a:pt x="379145" y="314821"/>
                   </a:lnTo>
                   <a:lnTo>
                     <a:pt x="379145" y="100009"/>
@@ -28898,6 +28942,690 @@
             </a:prstGeom>
             <a:solidFill>
               <a:schemeClr val="bg1"/>
+            </a:solidFill>
+            <a:ln>
+              <a:noFill/>
+            </a:ln>
+          </p:spPr>
+          <p:style>
+            <a:lnRef idx="2">
+              <a:schemeClr val="accent1">
+                <a:shade val="15000"/>
+              </a:schemeClr>
+            </a:lnRef>
+            <a:fillRef idx="1">
+              <a:schemeClr val="accent1"/>
+            </a:fillRef>
+            <a:effectRef idx="0">
+              <a:schemeClr val="accent1"/>
+            </a:effectRef>
+            <a:fontRef idx="minor">
+              <a:schemeClr val="lt1"/>
+            </a:fontRef>
+          </p:style>
+          <p:txBody>
+            <a:bodyPr wrap="square" rtlCol="0" anchor="ctr">
+              <a:noAutofit/>
+            </a:bodyPr>
+            <a:lstStyle/>
+            <a:p>
+              <a:pPr algn="ctr"/>
+              <a:endParaRPr lang="ko-KR" altLang="en-US"/>
+            </a:p>
+          </p:txBody>
+        </p:sp>
+      </p:grpSp>
+      <p:grpSp>
+        <p:nvGrpSpPr>
+          <p:cNvPr id="35" name="그룹 34">
+            <a:extLst>
+              <a:ext uri="{FF2B5EF4-FFF2-40B4-BE49-F238E27FC236}">
+                <a16:creationId xmlns:a16="http://schemas.microsoft.com/office/drawing/2014/main" id="{14883344-9E72-0543-99E7-A8F6A24E5877}"/>
+              </a:ext>
+            </a:extLst>
+          </p:cNvPr>
+          <p:cNvGrpSpPr/>
+          <p:nvPr/>
+        </p:nvGrpSpPr>
+        <p:grpSpPr>
+          <a:xfrm>
+            <a:off x="5815323" y="2335722"/>
+            <a:ext cx="1440000" cy="1440000"/>
+            <a:chOff x="5815323" y="2335722"/>
+            <a:chExt cx="1440000" cy="1440000"/>
+          </a:xfrm>
+        </p:grpSpPr>
+        <p:sp>
+          <p:nvSpPr>
+            <p:cNvPr id="32" name="팔각형 31">
+              <a:extLst>
+                <a:ext uri="{FF2B5EF4-FFF2-40B4-BE49-F238E27FC236}">
+                  <a16:creationId xmlns:a16="http://schemas.microsoft.com/office/drawing/2014/main" id="{772DCD06-B113-3A05-5A0E-4E76A554B57A}"/>
+                </a:ext>
+              </a:extLst>
+            </p:cNvPr>
+            <p:cNvSpPr/>
+            <p:nvPr/>
+          </p:nvSpPr>
+          <p:spPr>
+            <a:xfrm>
+              <a:off x="5815323" y="2335722"/>
+              <a:ext cx="1440000" cy="1440000"/>
+            </a:xfrm>
+            <a:prstGeom prst="octagon">
+              <a:avLst>
+                <a:gd name="adj" fmla="val 15079"/>
+              </a:avLst>
+            </a:prstGeom>
+            <a:solidFill>
+              <a:srgbClr val="F05138"/>
+            </a:solidFill>
+            <a:ln>
+              <a:noFill/>
+            </a:ln>
+          </p:spPr>
+          <p:style>
+            <a:lnRef idx="2">
+              <a:schemeClr val="accent1">
+                <a:shade val="15000"/>
+              </a:schemeClr>
+            </a:lnRef>
+            <a:fillRef idx="1">
+              <a:schemeClr val="accent1"/>
+            </a:fillRef>
+            <a:effectRef idx="0">
+              <a:schemeClr val="accent1"/>
+            </a:effectRef>
+            <a:fontRef idx="minor">
+              <a:schemeClr val="lt1"/>
+            </a:fontRef>
+          </p:style>
+          <p:txBody>
+            <a:bodyPr rtlCol="0" anchor="ctr"/>
+            <a:lstStyle/>
+            <a:p>
+              <a:pPr algn="ctr"/>
+              <a:endParaRPr lang="ko-KR" altLang="en-US"/>
+            </a:p>
+          </p:txBody>
+        </p:sp>
+        <p:sp>
+          <p:nvSpPr>
+            <p:cNvPr id="41" name="자유형: 도형 40">
+              <a:extLst>
+                <a:ext uri="{FF2B5EF4-FFF2-40B4-BE49-F238E27FC236}">
+                  <a16:creationId xmlns:a16="http://schemas.microsoft.com/office/drawing/2014/main" id="{95E01D23-C16F-601E-EDC8-0BA64DA03F67}"/>
+                </a:ext>
+              </a:extLst>
+            </p:cNvPr>
+            <p:cNvSpPr/>
+            <p:nvPr/>
+          </p:nvSpPr>
+          <p:spPr>
+            <a:xfrm>
+              <a:off x="6013915" y="2520418"/>
+              <a:ext cx="969008" cy="969008"/>
+            </a:xfrm>
+            <a:custGeom>
+              <a:avLst/>
+              <a:gdLst>
+                <a:gd name="connsiteX0" fmla="*/ 570722 w 969008"/>
+                <a:gd name="connsiteY0" fmla="*/ 0 h 969008"/>
+                <a:gd name="connsiteX1" fmla="*/ 685195 w 969008"/>
+                <a:gd name="connsiteY1" fmla="*/ 0 h 969008"/>
+                <a:gd name="connsiteX2" fmla="*/ 969008 w 969008"/>
+                <a:gd name="connsiteY2" fmla="*/ 283813 h 969008"/>
+                <a:gd name="connsiteX3" fmla="*/ 969008 w 969008"/>
+                <a:gd name="connsiteY3" fmla="*/ 685195 h 969008"/>
+                <a:gd name="connsiteX4" fmla="*/ 685195 w 969008"/>
+                <a:gd name="connsiteY4" fmla="*/ 969008 h 969008"/>
+                <a:gd name="connsiteX5" fmla="*/ 283813 w 969008"/>
+                <a:gd name="connsiteY5" fmla="*/ 969008 h 969008"/>
+                <a:gd name="connsiteX6" fmla="*/ 0 w 969008"/>
+                <a:gd name="connsiteY6" fmla="*/ 685195 h 969008"/>
+                <a:gd name="connsiteX7" fmla="*/ 0 w 969008"/>
+                <a:gd name="connsiteY7" fmla="*/ 574396 h 969008"/>
+                <a:gd name="connsiteX8" fmla="*/ 206894 w 969008"/>
+                <a:gd name="connsiteY8" fmla="*/ 781290 h 969008"/>
+                <a:gd name="connsiteX9" fmla="*/ 499494 w 969008"/>
+                <a:gd name="connsiteY9" fmla="*/ 781290 h 969008"/>
+                <a:gd name="connsiteX10" fmla="*/ 706388 w 969008"/>
+                <a:gd name="connsiteY10" fmla="*/ 574396 h 969008"/>
+                <a:gd name="connsiteX11" fmla="*/ 706388 w 969008"/>
+                <a:gd name="connsiteY11" fmla="*/ 570722 h 969008"/>
+                <a:gd name="connsiteX12" fmla="*/ 777616 w 969008"/>
+                <a:gd name="connsiteY12" fmla="*/ 499494 h 969008"/>
+                <a:gd name="connsiteX13" fmla="*/ 777616 w 969008"/>
+                <a:gd name="connsiteY13" fmla="*/ 206894 h 969008"/>
+              </a:gdLst>
+              <a:ahLst/>
+              <a:cxnLst>
+                <a:cxn ang="0">
+                  <a:pos x="connsiteX0" y="connsiteY0"/>
+                </a:cxn>
+                <a:cxn ang="0">
+                  <a:pos x="connsiteX1" y="connsiteY1"/>
+                </a:cxn>
+                <a:cxn ang="0">
+                  <a:pos x="connsiteX2" y="connsiteY2"/>
+                </a:cxn>
+                <a:cxn ang="0">
+                  <a:pos x="connsiteX3" y="connsiteY3"/>
+                </a:cxn>
+                <a:cxn ang="0">
+                  <a:pos x="connsiteX4" y="connsiteY4"/>
+                </a:cxn>
+                <a:cxn ang="0">
+                  <a:pos x="connsiteX5" y="connsiteY5"/>
+                </a:cxn>
+                <a:cxn ang="0">
+                  <a:pos x="connsiteX6" y="connsiteY6"/>
+                </a:cxn>
+                <a:cxn ang="0">
+                  <a:pos x="connsiteX7" y="connsiteY7"/>
+                </a:cxn>
+                <a:cxn ang="0">
+                  <a:pos x="connsiteX8" y="connsiteY8"/>
+                </a:cxn>
+                <a:cxn ang="0">
+                  <a:pos x="connsiteX9" y="connsiteY9"/>
+                </a:cxn>
+                <a:cxn ang="0">
+                  <a:pos x="connsiteX10" y="connsiteY10"/>
+                </a:cxn>
+                <a:cxn ang="0">
+                  <a:pos x="connsiteX11" y="connsiteY11"/>
+                </a:cxn>
+                <a:cxn ang="0">
+                  <a:pos x="connsiteX12" y="connsiteY12"/>
+                </a:cxn>
+                <a:cxn ang="0">
+                  <a:pos x="connsiteX13" y="connsiteY13"/>
+                </a:cxn>
+              </a:cxnLst>
+              <a:rect l="l" t="t" r="r" b="b"/>
+              <a:pathLst>
+                <a:path w="969008" h="969008">
+                  <a:moveTo>
+                    <a:pt x="570722" y="0"/>
+                  </a:moveTo>
+                  <a:lnTo>
+                    <a:pt x="685195" y="0"/>
+                  </a:lnTo>
+                  <a:lnTo>
+                    <a:pt x="969008" y="283813"/>
+                  </a:lnTo>
+                  <a:lnTo>
+                    <a:pt x="969008" y="685195"/>
+                  </a:lnTo>
+                  <a:lnTo>
+                    <a:pt x="685195" y="969008"/>
+                  </a:lnTo>
+                  <a:lnTo>
+                    <a:pt x="283813" y="969008"/>
+                  </a:lnTo>
+                  <a:lnTo>
+                    <a:pt x="0" y="685195"/>
+                  </a:lnTo>
+                  <a:lnTo>
+                    <a:pt x="0" y="574396"/>
+                  </a:lnTo>
+                  <a:lnTo>
+                    <a:pt x="206894" y="781290"/>
+                  </a:lnTo>
+                  <a:lnTo>
+                    <a:pt x="499494" y="781290"/>
+                  </a:lnTo>
+                  <a:lnTo>
+                    <a:pt x="706388" y="574396"/>
+                  </a:lnTo>
+                  <a:lnTo>
+                    <a:pt x="706388" y="570722"/>
+                  </a:lnTo>
+                  <a:lnTo>
+                    <a:pt x="777616" y="499494"/>
+                  </a:lnTo>
+                  <a:lnTo>
+                    <a:pt x="777616" y="206894"/>
+                  </a:lnTo>
+                  <a:close/>
+                </a:path>
+              </a:pathLst>
+            </a:custGeom>
+            <a:solidFill>
+              <a:schemeClr val="bg1"/>
+            </a:solidFill>
+            <a:ln>
+              <a:noFill/>
+            </a:ln>
+          </p:spPr>
+          <p:style>
+            <a:lnRef idx="2">
+              <a:schemeClr val="accent1">
+                <a:shade val="15000"/>
+              </a:schemeClr>
+            </a:lnRef>
+            <a:fillRef idx="1">
+              <a:schemeClr val="accent1"/>
+            </a:fillRef>
+            <a:effectRef idx="0">
+              <a:schemeClr val="accent1"/>
+            </a:effectRef>
+            <a:fontRef idx="minor">
+              <a:schemeClr val="lt1"/>
+            </a:fontRef>
+          </p:style>
+          <p:txBody>
+            <a:bodyPr wrap="square" rtlCol="0" anchor="ctr">
+              <a:noAutofit/>
+            </a:bodyPr>
+            <a:lstStyle/>
+            <a:p>
+              <a:pPr algn="ctr"/>
+              <a:endParaRPr lang="ko-KR" altLang="en-US"/>
+            </a:p>
+          </p:txBody>
+        </p:sp>
+        <p:sp>
+          <p:nvSpPr>
+            <p:cNvPr id="42" name="팔각형 41">
+              <a:extLst>
+                <a:ext uri="{FF2B5EF4-FFF2-40B4-BE49-F238E27FC236}">
+                  <a16:creationId xmlns:a16="http://schemas.microsoft.com/office/drawing/2014/main" id="{86391C80-231C-984E-C4AE-8244776EC6C9}"/>
+                </a:ext>
+              </a:extLst>
+            </p:cNvPr>
+            <p:cNvSpPr/>
+            <p:nvPr/>
+          </p:nvSpPr>
+          <p:spPr>
+            <a:xfrm rot="2700000">
+              <a:off x="6037327" y="2958024"/>
+              <a:ext cx="1173431" cy="136525"/>
+            </a:xfrm>
+            <a:prstGeom prst="octagon">
+              <a:avLst/>
+            </a:prstGeom>
+            <a:solidFill>
+              <a:schemeClr val="bg1"/>
+            </a:solidFill>
+            <a:ln>
+              <a:noFill/>
+            </a:ln>
+          </p:spPr>
+          <p:style>
+            <a:lnRef idx="2">
+              <a:schemeClr val="accent1">
+                <a:shade val="15000"/>
+              </a:schemeClr>
+            </a:lnRef>
+            <a:fillRef idx="1">
+              <a:schemeClr val="accent1"/>
+            </a:fillRef>
+            <a:effectRef idx="0">
+              <a:schemeClr val="accent1"/>
+            </a:effectRef>
+            <a:fontRef idx="minor">
+              <a:schemeClr val="lt1"/>
+            </a:fontRef>
+          </p:style>
+          <p:txBody>
+            <a:bodyPr wrap="square" rtlCol="0" anchor="ctr">
+              <a:noAutofit/>
+            </a:bodyPr>
+            <a:lstStyle/>
+            <a:p>
+              <a:pPr algn="ctr"/>
+              <a:endParaRPr lang="ko-KR" altLang="en-US"/>
+            </a:p>
+          </p:txBody>
+        </p:sp>
+        <p:sp>
+          <p:nvSpPr>
+            <p:cNvPr id="43" name="팔각형 42">
+              <a:extLst>
+                <a:ext uri="{FF2B5EF4-FFF2-40B4-BE49-F238E27FC236}">
+                  <a16:creationId xmlns:a16="http://schemas.microsoft.com/office/drawing/2014/main" id="{99A5898B-4063-E7F6-DFFC-7E60D8EEE59E}"/>
+                </a:ext>
+              </a:extLst>
+            </p:cNvPr>
+            <p:cNvSpPr/>
+            <p:nvPr/>
+          </p:nvSpPr>
+          <p:spPr>
+            <a:xfrm rot="2700000">
+              <a:off x="5928129" y="2936415"/>
+              <a:ext cx="978927" cy="136525"/>
+            </a:xfrm>
+            <a:prstGeom prst="octagon">
+              <a:avLst/>
+            </a:prstGeom>
+            <a:solidFill>
+              <a:schemeClr val="bg1"/>
+            </a:solidFill>
+            <a:ln>
+              <a:noFill/>
+            </a:ln>
+          </p:spPr>
+          <p:style>
+            <a:lnRef idx="2">
+              <a:schemeClr val="accent1">
+                <a:shade val="15000"/>
+              </a:schemeClr>
+            </a:lnRef>
+            <a:fillRef idx="1">
+              <a:schemeClr val="accent1"/>
+            </a:fillRef>
+            <a:effectRef idx="0">
+              <a:schemeClr val="accent1"/>
+            </a:effectRef>
+            <a:fontRef idx="minor">
+              <a:schemeClr val="lt1"/>
+            </a:fontRef>
+          </p:style>
+          <p:txBody>
+            <a:bodyPr wrap="square" rtlCol="0" anchor="ctr">
+              <a:noAutofit/>
+            </a:bodyPr>
+            <a:lstStyle/>
+            <a:p>
+              <a:pPr algn="ctr"/>
+              <a:endParaRPr lang="ko-KR" altLang="en-US" dirty="0"/>
+            </a:p>
+          </p:txBody>
+        </p:sp>
+        <p:sp>
+          <p:nvSpPr>
+            <p:cNvPr id="45" name="팔각형 44">
+              <a:extLst>
+                <a:ext uri="{FF2B5EF4-FFF2-40B4-BE49-F238E27FC236}">
+                  <a16:creationId xmlns:a16="http://schemas.microsoft.com/office/drawing/2014/main" id="{C9ACDAA4-D5A4-9EA0-AEF8-8C250DD41814}"/>
+                </a:ext>
+              </a:extLst>
+            </p:cNvPr>
+            <p:cNvSpPr/>
+            <p:nvPr/>
+          </p:nvSpPr>
+          <p:spPr>
+            <a:xfrm rot="2700000" flipV="1">
+              <a:off x="6017013" y="2734450"/>
+              <a:ext cx="514226" cy="71716"/>
+            </a:xfrm>
+            <a:prstGeom prst="octagon">
+              <a:avLst/>
+            </a:prstGeom>
+            <a:solidFill>
+              <a:srgbClr val="F05138"/>
+            </a:solidFill>
+            <a:ln>
+              <a:noFill/>
+            </a:ln>
+          </p:spPr>
+          <p:style>
+            <a:lnRef idx="2">
+              <a:schemeClr val="accent1">
+                <a:shade val="15000"/>
+              </a:schemeClr>
+            </a:lnRef>
+            <a:fillRef idx="1">
+              <a:schemeClr val="accent1"/>
+            </a:fillRef>
+            <a:effectRef idx="0">
+              <a:schemeClr val="accent1"/>
+            </a:effectRef>
+            <a:fontRef idx="minor">
+              <a:schemeClr val="lt1"/>
+            </a:fontRef>
+          </p:style>
+          <p:txBody>
+            <a:bodyPr wrap="square" rtlCol="0" anchor="ctr">
+              <a:noAutofit/>
+            </a:bodyPr>
+            <a:lstStyle/>
+            <a:p>
+              <a:pPr algn="ctr"/>
+              <a:endParaRPr lang="ko-KR" altLang="en-US" dirty="0"/>
+            </a:p>
+          </p:txBody>
+        </p:sp>
+        <p:sp>
+          <p:nvSpPr>
+            <p:cNvPr id="60" name="직사각형 59">
+              <a:extLst>
+                <a:ext uri="{FF2B5EF4-FFF2-40B4-BE49-F238E27FC236}">
+                  <a16:creationId xmlns:a16="http://schemas.microsoft.com/office/drawing/2014/main" id="{4D627799-F4AC-9A6E-3FB0-4F1C0EA0AE40}"/>
+                </a:ext>
+              </a:extLst>
+            </p:cNvPr>
+            <p:cNvSpPr/>
+            <p:nvPr/>
+          </p:nvSpPr>
+          <p:spPr>
+            <a:xfrm>
+              <a:off x="6794435" y="3302856"/>
+              <a:ext cx="101600" cy="89051"/>
+            </a:xfrm>
+            <a:prstGeom prst="rect">
+              <a:avLst/>
+            </a:prstGeom>
+            <a:solidFill>
+              <a:schemeClr val="bg1"/>
+            </a:solidFill>
+            <a:ln>
+              <a:noFill/>
+            </a:ln>
+          </p:spPr>
+          <p:style>
+            <a:lnRef idx="2">
+              <a:schemeClr val="accent1">
+                <a:shade val="15000"/>
+              </a:schemeClr>
+            </a:lnRef>
+            <a:fillRef idx="1">
+              <a:schemeClr val="accent1"/>
+            </a:fillRef>
+            <a:effectRef idx="0">
+              <a:schemeClr val="accent1"/>
+            </a:effectRef>
+            <a:fontRef idx="minor">
+              <a:schemeClr val="lt1"/>
+            </a:fontRef>
+          </p:style>
+          <p:txBody>
+            <a:bodyPr wrap="square" rtlCol="0" anchor="ctr">
+              <a:noAutofit/>
+            </a:bodyPr>
+            <a:lstStyle/>
+            <a:p>
+              <a:pPr algn="ctr"/>
+              <a:endParaRPr lang="ko-KR" altLang="en-US"/>
+            </a:p>
+          </p:txBody>
+        </p:sp>
+        <p:sp>
+          <p:nvSpPr>
+            <p:cNvPr id="72" name="다이아몬드 71">
+              <a:extLst>
+                <a:ext uri="{FF2B5EF4-FFF2-40B4-BE49-F238E27FC236}">
+                  <a16:creationId xmlns:a16="http://schemas.microsoft.com/office/drawing/2014/main" id="{80DC879F-46BE-C302-6D64-6626CA7A4885}"/>
+                </a:ext>
+              </a:extLst>
+            </p:cNvPr>
+            <p:cNvSpPr/>
+            <p:nvPr/>
+          </p:nvSpPr>
+          <p:spPr>
+            <a:xfrm>
+              <a:off x="6939849" y="3384669"/>
+              <a:ext cx="103170" cy="103170"/>
+            </a:xfrm>
+            <a:prstGeom prst="diamond">
+              <a:avLst/>
+            </a:prstGeom>
+            <a:solidFill>
+              <a:schemeClr val="bg1"/>
+            </a:solidFill>
+            <a:ln>
+              <a:noFill/>
+            </a:ln>
+          </p:spPr>
+          <p:style>
+            <a:lnRef idx="2">
+              <a:schemeClr val="accent1">
+                <a:shade val="15000"/>
+              </a:schemeClr>
+            </a:lnRef>
+            <a:fillRef idx="1">
+              <a:schemeClr val="accent1"/>
+            </a:fillRef>
+            <a:effectRef idx="0">
+              <a:schemeClr val="accent1"/>
+            </a:effectRef>
+            <a:fontRef idx="minor">
+              <a:schemeClr val="lt1"/>
+            </a:fontRef>
+          </p:style>
+          <p:txBody>
+            <a:bodyPr wrap="square" rtlCol="0" anchor="ctr">
+              <a:noAutofit/>
+            </a:bodyPr>
+            <a:lstStyle/>
+            <a:p>
+              <a:pPr algn="ctr"/>
+              <a:endParaRPr lang="ko-KR" altLang="en-US"/>
+            </a:p>
+          </p:txBody>
+        </p:sp>
+        <p:sp>
+          <p:nvSpPr>
+            <p:cNvPr id="91" name="직사각형 90">
+              <a:extLst>
+                <a:ext uri="{FF2B5EF4-FFF2-40B4-BE49-F238E27FC236}">
+                  <a16:creationId xmlns:a16="http://schemas.microsoft.com/office/drawing/2014/main" id="{D2C955EE-23C0-DB5D-69DD-7D3D4A41755E}"/>
+                </a:ext>
+              </a:extLst>
+            </p:cNvPr>
+            <p:cNvSpPr/>
+            <p:nvPr/>
+          </p:nvSpPr>
+          <p:spPr>
+            <a:xfrm flipH="1">
+              <a:off x="6172989" y="2447492"/>
+              <a:ext cx="184150" cy="184150"/>
+            </a:xfrm>
+            <a:prstGeom prst="rect">
+              <a:avLst/>
+            </a:prstGeom>
+            <a:solidFill>
+              <a:srgbClr val="F05138"/>
+            </a:solidFill>
+            <a:ln>
+              <a:noFill/>
+            </a:ln>
+          </p:spPr>
+          <p:style>
+            <a:lnRef idx="2">
+              <a:schemeClr val="accent1">
+                <a:shade val="15000"/>
+              </a:schemeClr>
+            </a:lnRef>
+            <a:fillRef idx="1">
+              <a:schemeClr val="accent1"/>
+            </a:fillRef>
+            <a:effectRef idx="0">
+              <a:schemeClr val="accent1"/>
+            </a:effectRef>
+            <a:fontRef idx="minor">
+              <a:schemeClr val="lt1"/>
+            </a:fontRef>
+          </p:style>
+          <p:txBody>
+            <a:bodyPr wrap="square" rtlCol="0" anchor="ctr">
+              <a:noAutofit/>
+            </a:bodyPr>
+            <a:lstStyle/>
+            <a:p>
+              <a:pPr algn="ctr"/>
+              <a:endParaRPr lang="ko-KR" altLang="en-US"/>
+            </a:p>
+          </p:txBody>
+        </p:sp>
+        <p:sp>
+          <p:nvSpPr>
+            <p:cNvPr id="92" name="직사각형 91">
+              <a:extLst>
+                <a:ext uri="{FF2B5EF4-FFF2-40B4-BE49-F238E27FC236}">
+                  <a16:creationId xmlns:a16="http://schemas.microsoft.com/office/drawing/2014/main" id="{DAB9C8BB-DB66-9463-624E-EA5DB6D73FC0}"/>
+                </a:ext>
+              </a:extLst>
+            </p:cNvPr>
+            <p:cNvSpPr/>
+            <p:nvPr/>
+          </p:nvSpPr>
+          <p:spPr>
+            <a:xfrm flipH="1">
+              <a:off x="5910745" y="2631642"/>
+              <a:ext cx="184150" cy="184150"/>
+            </a:xfrm>
+            <a:prstGeom prst="rect">
+              <a:avLst/>
+            </a:prstGeom>
+            <a:solidFill>
+              <a:srgbClr val="F05138"/>
+            </a:solidFill>
+            <a:ln>
+              <a:noFill/>
+            </a:ln>
+          </p:spPr>
+          <p:style>
+            <a:lnRef idx="2">
+              <a:schemeClr val="accent1">
+                <a:shade val="15000"/>
+              </a:schemeClr>
+            </a:lnRef>
+            <a:fillRef idx="1">
+              <a:schemeClr val="accent1"/>
+            </a:fillRef>
+            <a:effectRef idx="0">
+              <a:schemeClr val="accent1"/>
+            </a:effectRef>
+            <a:fontRef idx="minor">
+              <a:schemeClr val="lt1"/>
+            </a:fontRef>
+          </p:style>
+          <p:txBody>
+            <a:bodyPr wrap="square" rtlCol="0" anchor="ctr">
+              <a:noAutofit/>
+            </a:bodyPr>
+            <a:lstStyle/>
+            <a:p>
+              <a:pPr algn="ctr"/>
+              <a:endParaRPr lang="ko-KR" altLang="en-US"/>
+            </a:p>
+          </p:txBody>
+        </p:sp>
+        <p:sp>
+          <p:nvSpPr>
+            <p:cNvPr id="24" name="다이아몬드 23">
+              <a:extLst>
+                <a:ext uri="{FF2B5EF4-FFF2-40B4-BE49-F238E27FC236}">
+                  <a16:creationId xmlns:a16="http://schemas.microsoft.com/office/drawing/2014/main" id="{F2598843-90F1-6B9C-2792-CB167021A58A}"/>
+                </a:ext>
+              </a:extLst>
+            </p:cNvPr>
+            <p:cNvSpPr/>
+            <p:nvPr/>
+          </p:nvSpPr>
+          <p:spPr>
+            <a:xfrm>
+              <a:off x="6966989" y="3399049"/>
+              <a:ext cx="212308" cy="212308"/>
+            </a:xfrm>
+            <a:prstGeom prst="diamond">
+              <a:avLst/>
+            </a:prstGeom>
+            <a:solidFill>
+              <a:srgbClr val="F05138"/>
             </a:solidFill>
             <a:ln>
               <a:noFill/>

</xml_diff>

<commit_message>
Modifiec MATLAB icon a bit
</commit_message>
<xml_diff>
--- a/tepk2924_Custon_Icon.pptx
+++ b/tepk2924_Custon_Icon.pptx
@@ -211,7 +211,7 @@
           <a:p>
             <a:fld id="{10460FAE-A4BB-46CF-AB3F-8A65ECE16F8C}" type="datetimeFigureOut">
               <a:rPr lang="ko-KR" altLang="en-US" smtClean="0"/>
-              <a:t>2026-08-27</a:t>
+              <a:t>2026-08-28</a:t>
             </a:fld>
             <a:endParaRPr lang="ko-KR" altLang="en-US"/>
           </a:p>
@@ -625,7 +625,7 @@
           <a:p>
             <a:fld id="{5514A77A-5394-47DD-9A3D-6F42195EF4ED}" type="datetimeFigureOut">
               <a:rPr lang="ko-KR" altLang="en-US" smtClean="0"/>
-              <a:t>2026-08-27</a:t>
+              <a:t>2026-08-28</a:t>
             </a:fld>
             <a:endParaRPr lang="ko-KR" altLang="en-US"/>
           </a:p>
@@ -823,7 +823,7 @@
           <a:p>
             <a:fld id="{5514A77A-5394-47DD-9A3D-6F42195EF4ED}" type="datetimeFigureOut">
               <a:rPr lang="ko-KR" altLang="en-US" smtClean="0"/>
-              <a:t>2026-08-27</a:t>
+              <a:t>2026-08-28</a:t>
             </a:fld>
             <a:endParaRPr lang="ko-KR" altLang="en-US"/>
           </a:p>
@@ -1031,7 +1031,7 @@
           <a:p>
             <a:fld id="{5514A77A-5394-47DD-9A3D-6F42195EF4ED}" type="datetimeFigureOut">
               <a:rPr lang="ko-KR" altLang="en-US" smtClean="0"/>
-              <a:t>2026-08-27</a:t>
+              <a:t>2026-08-28</a:t>
             </a:fld>
             <a:endParaRPr lang="ko-KR" altLang="en-US"/>
           </a:p>
@@ -1229,7 +1229,7 @@
           <a:p>
             <a:fld id="{5514A77A-5394-47DD-9A3D-6F42195EF4ED}" type="datetimeFigureOut">
               <a:rPr lang="ko-KR" altLang="en-US" smtClean="0"/>
-              <a:t>2026-08-27</a:t>
+              <a:t>2026-08-28</a:t>
             </a:fld>
             <a:endParaRPr lang="ko-KR" altLang="en-US"/>
           </a:p>
@@ -1504,7 +1504,7 @@
           <a:p>
             <a:fld id="{5514A77A-5394-47DD-9A3D-6F42195EF4ED}" type="datetimeFigureOut">
               <a:rPr lang="ko-KR" altLang="en-US" smtClean="0"/>
-              <a:t>2026-08-27</a:t>
+              <a:t>2026-08-28</a:t>
             </a:fld>
             <a:endParaRPr lang="ko-KR" altLang="en-US"/>
           </a:p>
@@ -1769,7 +1769,7 @@
           <a:p>
             <a:fld id="{5514A77A-5394-47DD-9A3D-6F42195EF4ED}" type="datetimeFigureOut">
               <a:rPr lang="ko-KR" altLang="en-US" smtClean="0"/>
-              <a:t>2026-08-27</a:t>
+              <a:t>2026-08-28</a:t>
             </a:fld>
             <a:endParaRPr lang="ko-KR" altLang="en-US"/>
           </a:p>
@@ -2181,7 +2181,7 @@
           <a:p>
             <a:fld id="{5514A77A-5394-47DD-9A3D-6F42195EF4ED}" type="datetimeFigureOut">
               <a:rPr lang="ko-KR" altLang="en-US" smtClean="0"/>
-              <a:t>2026-08-27</a:t>
+              <a:t>2026-08-28</a:t>
             </a:fld>
             <a:endParaRPr lang="ko-KR" altLang="en-US"/>
           </a:p>
@@ -2322,7 +2322,7 @@
           <a:p>
             <a:fld id="{5514A77A-5394-47DD-9A3D-6F42195EF4ED}" type="datetimeFigureOut">
               <a:rPr lang="ko-KR" altLang="en-US" smtClean="0"/>
-              <a:t>2026-08-27</a:t>
+              <a:t>2026-08-28</a:t>
             </a:fld>
             <a:endParaRPr lang="ko-KR" altLang="en-US"/>
           </a:p>
@@ -2435,7 +2435,7 @@
           <a:p>
             <a:fld id="{5514A77A-5394-47DD-9A3D-6F42195EF4ED}" type="datetimeFigureOut">
               <a:rPr lang="ko-KR" altLang="en-US" smtClean="0"/>
-              <a:t>2026-08-27</a:t>
+              <a:t>2026-08-28</a:t>
             </a:fld>
             <a:endParaRPr lang="ko-KR" altLang="en-US"/>
           </a:p>
@@ -2746,7 +2746,7 @@
           <a:p>
             <a:fld id="{5514A77A-5394-47DD-9A3D-6F42195EF4ED}" type="datetimeFigureOut">
               <a:rPr lang="ko-KR" altLang="en-US" smtClean="0"/>
-              <a:t>2026-08-27</a:t>
+              <a:t>2026-08-28</a:t>
             </a:fld>
             <a:endParaRPr lang="ko-KR" altLang="en-US"/>
           </a:p>
@@ -3034,7 +3034,7 @@
           <a:p>
             <a:fld id="{5514A77A-5394-47DD-9A3D-6F42195EF4ED}" type="datetimeFigureOut">
               <a:rPr lang="ko-KR" altLang="en-US" smtClean="0"/>
-              <a:t>2026-08-27</a:t>
+              <a:t>2026-08-28</a:t>
             </a:fld>
             <a:endParaRPr lang="ko-KR" altLang="en-US"/>
           </a:p>
@@ -3275,7 +3275,7 @@
           <a:p>
             <a:fld id="{5514A77A-5394-47DD-9A3D-6F42195EF4ED}" type="datetimeFigureOut">
               <a:rPr lang="ko-KR" altLang="en-US" smtClean="0"/>
-              <a:t>2026-08-27</a:t>
+              <a:t>2026-08-28</a:t>
             </a:fld>
             <a:endParaRPr lang="ko-KR" altLang="en-US"/>
           </a:p>
@@ -30158,10 +30158,10 @@
       </p:grpSp>
       <p:grpSp>
         <p:nvGrpSpPr>
-          <p:cNvPr id="121" name="그룹 120">
+          <p:cNvPr id="125" name="그룹 124">
             <a:extLst>
               <a:ext uri="{FF2B5EF4-FFF2-40B4-BE49-F238E27FC236}">
-                <a16:creationId xmlns:a16="http://schemas.microsoft.com/office/drawing/2014/main" id="{26B5658B-2A19-D383-56FA-42407B0AAC19}"/>
+                <a16:creationId xmlns:a16="http://schemas.microsoft.com/office/drawing/2014/main" id="{1132335C-B1FA-88EB-A895-193CE711E8F6}"/>
               </a:ext>
             </a:extLst>
           </p:cNvPr>
@@ -30170,9 +30170,9 @@
         </p:nvGrpSpPr>
         <p:grpSpPr>
           <a:xfrm>
-            <a:off x="9586493" y="2319484"/>
+            <a:off x="9631883" y="2309483"/>
             <a:ext cx="1440000" cy="1440000"/>
-            <a:chOff x="5376000" y="2496692"/>
+            <a:chOff x="9631883" y="2309483"/>
             <a:chExt cx="1440000" cy="1440000"/>
           </a:xfrm>
         </p:grpSpPr>
@@ -30190,7 +30190,7 @@
           </p:nvSpPr>
           <p:spPr>
             <a:xfrm>
-              <a:off x="5376000" y="2496692"/>
+              <a:off x="9631883" y="2309483"/>
               <a:ext cx="1440000" cy="1440000"/>
             </a:xfrm>
             <a:prstGeom prst="rect">
@@ -30230,10 +30230,10 @@
         </p:sp>
         <p:sp>
           <p:nvSpPr>
-            <p:cNvPr id="116" name="자유형: 도형 115">
+            <p:cNvPr id="85" name="자유형: 도형 84">
               <a:extLst>
                 <a:ext uri="{FF2B5EF4-FFF2-40B4-BE49-F238E27FC236}">
-                  <a16:creationId xmlns:a16="http://schemas.microsoft.com/office/drawing/2014/main" id="{9D850FE7-C200-0AC3-56B9-CA571C4660CA}"/>
+                  <a16:creationId xmlns:a16="http://schemas.microsoft.com/office/drawing/2014/main" id="{3DFF2861-BF10-6A16-89A2-E97E900FB94A}"/>
                 </a:ext>
               </a:extLst>
             </p:cNvPr>
@@ -30242,7 +30242,7 @@
           </p:nvSpPr>
           <p:spPr>
             <a:xfrm>
-              <a:off x="5441950" y="3098801"/>
+              <a:off x="9698959" y="2935424"/>
               <a:ext cx="541894" cy="398061"/>
             </a:xfrm>
             <a:custGeom>
@@ -30351,10 +30351,10 @@
         </p:sp>
         <p:sp>
           <p:nvSpPr>
-            <p:cNvPr id="117" name="자유형: 도형 116">
+            <p:cNvPr id="122" name="자유형: 도형 121">
               <a:extLst>
                 <a:ext uri="{FF2B5EF4-FFF2-40B4-BE49-F238E27FC236}">
-                  <a16:creationId xmlns:a16="http://schemas.microsoft.com/office/drawing/2014/main" id="{9F77A01F-EBDE-7B80-0E73-0CDA24FAA746}"/>
+                  <a16:creationId xmlns:a16="http://schemas.microsoft.com/office/drawing/2014/main" id="{1B8A99FF-79C3-C892-499D-AD55FC6C3141}"/>
                 </a:ext>
               </a:extLst>
             </p:cNvPr>
@@ -30363,34 +30363,34 @@
           </p:nvSpPr>
           <p:spPr>
             <a:xfrm>
-              <a:off x="5870566" y="2653734"/>
-              <a:ext cx="418433" cy="554489"/>
+              <a:off x="10151407" y="2492474"/>
+              <a:ext cx="400952" cy="537009"/>
             </a:xfrm>
             <a:custGeom>
               <a:avLst/>
               <a:gdLst>
-                <a:gd name="connsiteX0" fmla="*/ 870253 w 870253"/>
-                <a:gd name="connsiteY0" fmla="*/ 0 h 1153223"/>
-                <a:gd name="connsiteX1" fmla="*/ 870253 w 870253"/>
-                <a:gd name="connsiteY1" fmla="*/ 163125 h 1153223"/>
-                <a:gd name="connsiteX2" fmla="*/ 733728 w 870253"/>
-                <a:gd name="connsiteY2" fmla="*/ 299650 h 1153223"/>
-                <a:gd name="connsiteX3" fmla="*/ 736903 w 870253"/>
-                <a:gd name="connsiteY3" fmla="*/ 302825 h 1153223"/>
-                <a:gd name="connsiteX4" fmla="*/ 736903 w 870253"/>
-                <a:gd name="connsiteY4" fmla="*/ 496083 h 1153223"/>
-                <a:gd name="connsiteX5" fmla="*/ 566244 w 870253"/>
-                <a:gd name="connsiteY5" fmla="*/ 666742 h 1153223"/>
-                <a:gd name="connsiteX6" fmla="*/ 559690 w 870253"/>
-                <a:gd name="connsiteY6" fmla="*/ 666742 h 1153223"/>
-                <a:gd name="connsiteX7" fmla="*/ 559690 w 870253"/>
-                <a:gd name="connsiteY7" fmla="*/ 673296 h 1153223"/>
-                <a:gd name="connsiteX8" fmla="*/ 559690 w 870253"/>
-                <a:gd name="connsiteY8" fmla="*/ 876503 h 1153223"/>
-                <a:gd name="connsiteX9" fmla="*/ 282970 w 870253"/>
-                <a:gd name="connsiteY9" fmla="*/ 1153223 h 1153223"/>
-                <a:gd name="connsiteX10" fmla="*/ 0 w 870253"/>
-                <a:gd name="connsiteY10" fmla="*/ 870253 h 1153223"/>
+                <a:gd name="connsiteX0" fmla="*/ 400952 w 400952"/>
+                <a:gd name="connsiteY0" fmla="*/ 0 h 537009"/>
+                <a:gd name="connsiteX1" fmla="*/ 400952 w 400952"/>
+                <a:gd name="connsiteY1" fmla="*/ 78433 h 537009"/>
+                <a:gd name="connsiteX2" fmla="*/ 335309 w 400952"/>
+                <a:gd name="connsiteY2" fmla="*/ 144077 h 537009"/>
+                <a:gd name="connsiteX3" fmla="*/ 336835 w 400952"/>
+                <a:gd name="connsiteY3" fmla="*/ 145604 h 537009"/>
+                <a:gd name="connsiteX4" fmla="*/ 336835 w 400952"/>
+                <a:gd name="connsiteY4" fmla="*/ 238525 h 537009"/>
+                <a:gd name="connsiteX5" fmla="*/ 254779 w 400952"/>
+                <a:gd name="connsiteY5" fmla="*/ 320581 h 537009"/>
+                <a:gd name="connsiteX6" fmla="*/ 251628 w 400952"/>
+                <a:gd name="connsiteY6" fmla="*/ 320581 h 537009"/>
+                <a:gd name="connsiteX7" fmla="*/ 251628 w 400952"/>
+                <a:gd name="connsiteY7" fmla="*/ 323732 h 537009"/>
+                <a:gd name="connsiteX8" fmla="*/ 251628 w 400952"/>
+                <a:gd name="connsiteY8" fmla="*/ 421438 h 537009"/>
+                <a:gd name="connsiteX9" fmla="*/ 136056 w 400952"/>
+                <a:gd name="connsiteY9" fmla="*/ 537009 h 537009"/>
+                <a:gd name="connsiteX10" fmla="*/ 0 w 400952"/>
+                <a:gd name="connsiteY10" fmla="*/ 400953 h 537009"/>
               </a:gdLst>
               <a:ahLst/>
               <a:cxnLst>
@@ -30430,39 +30430,39 @@
               </a:cxnLst>
               <a:rect l="l" t="t" r="r" b="b"/>
               <a:pathLst>
-                <a:path w="870253" h="1153223">
+                <a:path w="400952" h="537009">
                   <a:moveTo>
-                    <a:pt x="870253" y="0"/>
+                    <a:pt x="400952" y="0"/>
                   </a:moveTo>
                   <a:lnTo>
-                    <a:pt x="870253" y="163125"/>
-                  </a:lnTo>
-                  <a:lnTo>
-                    <a:pt x="733728" y="299650"/>
-                  </a:lnTo>
-                  <a:lnTo>
-                    <a:pt x="736903" y="302825"/>
-                  </a:lnTo>
-                  <a:lnTo>
-                    <a:pt x="736903" y="496083"/>
-                  </a:lnTo>
-                  <a:lnTo>
-                    <a:pt x="566244" y="666742"/>
-                  </a:lnTo>
-                  <a:lnTo>
-                    <a:pt x="559690" y="666742"/>
-                  </a:lnTo>
-                  <a:lnTo>
-                    <a:pt x="559690" y="673296"/>
-                  </a:lnTo>
-                  <a:lnTo>
-                    <a:pt x="559690" y="876503"/>
-                  </a:lnTo>
-                  <a:lnTo>
-                    <a:pt x="282970" y="1153223"/>
-                  </a:lnTo>
-                  <a:lnTo>
-                    <a:pt x="0" y="870253"/>
+                    <a:pt x="400952" y="78433"/>
+                  </a:lnTo>
+                  <a:lnTo>
+                    <a:pt x="335309" y="144077"/>
+                  </a:lnTo>
+                  <a:lnTo>
+                    <a:pt x="336835" y="145604"/>
+                  </a:lnTo>
+                  <a:lnTo>
+                    <a:pt x="336835" y="238525"/>
+                  </a:lnTo>
+                  <a:lnTo>
+                    <a:pt x="254779" y="320581"/>
+                  </a:lnTo>
+                  <a:lnTo>
+                    <a:pt x="251628" y="320581"/>
+                  </a:lnTo>
+                  <a:lnTo>
+                    <a:pt x="251628" y="323732"/>
+                  </a:lnTo>
+                  <a:lnTo>
+                    <a:pt x="251628" y="421438"/>
+                  </a:lnTo>
+                  <a:lnTo>
+                    <a:pt x="136056" y="537009"/>
+                  </a:lnTo>
+                  <a:lnTo>
+                    <a:pt x="0" y="400953"/>
                   </a:lnTo>
                   <a:close/>
                 </a:path>
@@ -30512,10 +30512,10 @@
         </p:sp>
         <p:sp>
           <p:nvSpPr>
-            <p:cNvPr id="118" name="자유형: 도형 117">
+            <p:cNvPr id="115" name="자유형: 도형 114">
               <a:extLst>
                 <a:ext uri="{FF2B5EF4-FFF2-40B4-BE49-F238E27FC236}">
-                  <a16:creationId xmlns:a16="http://schemas.microsoft.com/office/drawing/2014/main" id="{2ED3307E-2D21-F874-D267-807FC980F6E6}"/>
+                  <a16:creationId xmlns:a16="http://schemas.microsoft.com/office/drawing/2014/main" id="{CB32712C-2438-BAE0-1B79-D76DE78F4CC8}"/>
                 </a:ext>
               </a:extLst>
             </p:cNvPr>
@@ -30524,108 +30524,98 @@
           </p:nvSpPr>
           <p:spPr>
             <a:xfrm>
-              <a:off x="5837127" y="2604191"/>
+              <a:off x="10100487" y="2442931"/>
               <a:ext cx="912923" cy="1225002"/>
             </a:xfrm>
             <a:custGeom>
               <a:avLst/>
               <a:gdLst>
-                <a:gd name="connsiteX0" fmla="*/ 1087143 w 1898686"/>
-                <a:gd name="connsiteY0" fmla="*/ 0 h 2547749"/>
-                <a:gd name="connsiteX1" fmla="*/ 1209498 w 1898686"/>
-                <a:gd name="connsiteY1" fmla="*/ 0 h 2547749"/>
-                <a:gd name="connsiteX2" fmla="*/ 1307797 w 1898686"/>
-                <a:gd name="connsiteY2" fmla="*/ 98299 h 2547749"/>
-                <a:gd name="connsiteX3" fmla="*/ 1307797 w 1898686"/>
-                <a:gd name="connsiteY3" fmla="*/ 246379 h 2547749"/>
-                <a:gd name="connsiteX4" fmla="*/ 1305368 w 1898686"/>
-                <a:gd name="connsiteY4" fmla="*/ 248808 h 2547749"/>
-                <a:gd name="connsiteX5" fmla="*/ 1415711 w 1898686"/>
-                <a:gd name="connsiteY5" fmla="*/ 359151 h 2547749"/>
-                <a:gd name="connsiteX6" fmla="*/ 1415711 w 1898686"/>
-                <a:gd name="connsiteY6" fmla="*/ 541664 h 2547749"/>
-                <a:gd name="connsiteX7" fmla="*/ 1419634 w 1898686"/>
-                <a:gd name="connsiteY7" fmla="*/ 541664 h 2547749"/>
-                <a:gd name="connsiteX8" fmla="*/ 1412147 w 1898686"/>
-                <a:gd name="connsiteY8" fmla="*/ 549151 h 2547749"/>
-                <a:gd name="connsiteX9" fmla="*/ 1535502 w 1898686"/>
-                <a:gd name="connsiteY9" fmla="*/ 672506 h 2547749"/>
-                <a:gd name="connsiteX10" fmla="*/ 1535502 w 1898686"/>
-                <a:gd name="connsiteY10" fmla="*/ 936039 h 2547749"/>
-                <a:gd name="connsiteX11" fmla="*/ 1537015 w 1898686"/>
-                <a:gd name="connsiteY11" fmla="*/ 936039 h 2547749"/>
-                <a:gd name="connsiteX12" fmla="*/ 1532352 w 1898686"/>
-                <a:gd name="connsiteY12" fmla="*/ 940702 h 2547749"/>
-                <a:gd name="connsiteX13" fmla="*/ 1695450 w 1898686"/>
-                <a:gd name="connsiteY13" fmla="*/ 1103800 h 2547749"/>
-                <a:gd name="connsiteX14" fmla="*/ 1695450 w 1898686"/>
-                <a:gd name="connsiteY14" fmla="*/ 1361036 h 2547749"/>
-                <a:gd name="connsiteX15" fmla="*/ 1704487 w 1898686"/>
-                <a:gd name="connsiteY15" fmla="*/ 1361036 h 2547749"/>
-                <a:gd name="connsiteX16" fmla="*/ 1698548 w 1898686"/>
-                <a:gd name="connsiteY16" fmla="*/ 1366975 h 2547749"/>
-                <a:gd name="connsiteX17" fmla="*/ 1898686 w 1898686"/>
-                <a:gd name="connsiteY17" fmla="*/ 1567113 h 2547749"/>
-                <a:gd name="connsiteX18" fmla="*/ 1898686 w 1898686"/>
-                <a:gd name="connsiteY18" fmla="*/ 1984004 h 2547749"/>
-                <a:gd name="connsiteX19" fmla="*/ 1706979 w 1898686"/>
-                <a:gd name="connsiteY19" fmla="*/ 1792297 h 2547749"/>
-                <a:gd name="connsiteX20" fmla="*/ 1704479 w 1898686"/>
-                <a:gd name="connsiteY20" fmla="*/ 1794797 h 2547749"/>
-                <a:gd name="connsiteX21" fmla="*/ 1704479 w 1898686"/>
-                <a:gd name="connsiteY21" fmla="*/ 1786987 h 2547749"/>
-                <a:gd name="connsiteX22" fmla="*/ 1337915 w 1898686"/>
-                <a:gd name="connsiteY22" fmla="*/ 1786987 h 2547749"/>
-                <a:gd name="connsiteX23" fmla="*/ 1333700 w 1898686"/>
-                <a:gd name="connsiteY23" fmla="*/ 1782772 h 2547749"/>
-                <a:gd name="connsiteX24" fmla="*/ 568723 w 1898686"/>
-                <a:gd name="connsiteY24" fmla="*/ 2547749 h 2547749"/>
-                <a:gd name="connsiteX25" fmla="*/ 422142 w 1898686"/>
-                <a:gd name="connsiteY25" fmla="*/ 2547749 h 2547749"/>
-                <a:gd name="connsiteX26" fmla="*/ 305139 w 1898686"/>
-                <a:gd name="connsiteY26" fmla="*/ 2430746 h 2547749"/>
-                <a:gd name="connsiteX27" fmla="*/ 305139 w 1898686"/>
-                <a:gd name="connsiteY27" fmla="*/ 2144350 h 2547749"/>
-                <a:gd name="connsiteX28" fmla="*/ 227176 w 1898686"/>
-                <a:gd name="connsiteY28" fmla="*/ 2066387 h 2547749"/>
-                <a:gd name="connsiteX29" fmla="*/ 225666 w 1898686"/>
-                <a:gd name="connsiteY29" fmla="*/ 2066387 h 2547749"/>
-                <a:gd name="connsiteX30" fmla="*/ 0 w 1898686"/>
-                <a:gd name="connsiteY30" fmla="*/ 1840721 h 2547749"/>
-                <a:gd name="connsiteX31" fmla="*/ 0 w 1898686"/>
-                <a:gd name="connsiteY31" fmla="*/ 1737895 h 2547749"/>
-                <a:gd name="connsiteX32" fmla="*/ 658932 w 1898686"/>
-                <a:gd name="connsiteY32" fmla="*/ 1078963 h 2547749"/>
-                <a:gd name="connsiteX33" fmla="*/ 661815 w 1898686"/>
-                <a:gd name="connsiteY33" fmla="*/ 1078963 h 2547749"/>
-                <a:gd name="connsiteX34" fmla="*/ 700202 w 1898686"/>
-                <a:gd name="connsiteY34" fmla="*/ 1040576 h 2547749"/>
-                <a:gd name="connsiteX35" fmla="*/ 700202 w 1898686"/>
-                <a:gd name="connsiteY35" fmla="*/ 1037693 h 2547749"/>
-                <a:gd name="connsiteX36" fmla="*/ 702712 w 1898686"/>
-                <a:gd name="connsiteY36" fmla="*/ 1035183 h 2547749"/>
-                <a:gd name="connsiteX37" fmla="*/ 700202 w 1898686"/>
-                <a:gd name="connsiteY37" fmla="*/ 1032673 h 2547749"/>
-                <a:gd name="connsiteX38" fmla="*/ 700202 w 1898686"/>
-                <a:gd name="connsiteY38" fmla="*/ 811379 h 2547749"/>
-                <a:gd name="connsiteX39" fmla="*/ 880958 w 1898686"/>
-                <a:gd name="connsiteY39" fmla="*/ 630623 h 2547749"/>
-                <a:gd name="connsiteX40" fmla="*/ 877394 w 1898686"/>
-                <a:gd name="connsiteY40" fmla="*/ 627059 h 2547749"/>
-                <a:gd name="connsiteX41" fmla="*/ 877394 w 1898686"/>
-                <a:gd name="connsiteY41" fmla="*/ 438991 h 2547749"/>
-                <a:gd name="connsiteX42" fmla="*/ 1003267 w 1898686"/>
-                <a:gd name="connsiteY42" fmla="*/ 313118 h 2547749"/>
-                <a:gd name="connsiteX43" fmla="*/ 1012474 w 1898686"/>
-                <a:gd name="connsiteY43" fmla="*/ 313118 h 2547749"/>
-                <a:gd name="connsiteX44" fmla="*/ 1012474 w 1898686"/>
-                <a:gd name="connsiteY44" fmla="*/ 303911 h 2547749"/>
-                <a:gd name="connsiteX45" fmla="*/ 1016000 w 1898686"/>
-                <a:gd name="connsiteY45" fmla="*/ 300385 h 2547749"/>
-                <a:gd name="connsiteX46" fmla="*/ 1012474 w 1898686"/>
-                <a:gd name="connsiteY46" fmla="*/ 296859 h 2547749"/>
-                <a:gd name="connsiteX47" fmla="*/ 1012474 w 1898686"/>
-                <a:gd name="connsiteY47" fmla="*/ 74669 h 2547749"/>
+                <a:gd name="connsiteX0" fmla="*/ 522718 w 912923"/>
+                <a:gd name="connsiteY0" fmla="*/ 0 h 1225002"/>
+                <a:gd name="connsiteX1" fmla="*/ 581549 w 912923"/>
+                <a:gd name="connsiteY1" fmla="*/ 0 h 1225002"/>
+                <a:gd name="connsiteX2" fmla="*/ 628813 w 912923"/>
+                <a:gd name="connsiteY2" fmla="*/ 47264 h 1225002"/>
+                <a:gd name="connsiteX3" fmla="*/ 628813 w 912923"/>
+                <a:gd name="connsiteY3" fmla="*/ 118464 h 1225002"/>
+                <a:gd name="connsiteX4" fmla="*/ 627645 w 912923"/>
+                <a:gd name="connsiteY4" fmla="*/ 119631 h 1225002"/>
+                <a:gd name="connsiteX5" fmla="*/ 680700 w 912923"/>
+                <a:gd name="connsiteY5" fmla="*/ 172686 h 1225002"/>
+                <a:gd name="connsiteX6" fmla="*/ 680700 w 912923"/>
+                <a:gd name="connsiteY6" fmla="*/ 260442 h 1225002"/>
+                <a:gd name="connsiteX7" fmla="*/ 682586 w 912923"/>
+                <a:gd name="connsiteY7" fmla="*/ 260442 h 1225002"/>
+                <a:gd name="connsiteX8" fmla="*/ 678986 w 912923"/>
+                <a:gd name="connsiteY8" fmla="*/ 264042 h 1225002"/>
+                <a:gd name="connsiteX9" fmla="*/ 738298 w 912923"/>
+                <a:gd name="connsiteY9" fmla="*/ 323353 h 1225002"/>
+                <a:gd name="connsiteX10" fmla="*/ 738298 w 912923"/>
+                <a:gd name="connsiteY10" fmla="*/ 450064 h 1225002"/>
+                <a:gd name="connsiteX11" fmla="*/ 739025 w 912923"/>
+                <a:gd name="connsiteY11" fmla="*/ 450064 h 1225002"/>
+                <a:gd name="connsiteX12" fmla="*/ 736783 w 912923"/>
+                <a:gd name="connsiteY12" fmla="*/ 452306 h 1225002"/>
+                <a:gd name="connsiteX13" fmla="*/ 815204 w 912923"/>
+                <a:gd name="connsiteY13" fmla="*/ 530726 h 1225002"/>
+                <a:gd name="connsiteX14" fmla="*/ 815204 w 912923"/>
+                <a:gd name="connsiteY14" fmla="*/ 654410 h 1225002"/>
+                <a:gd name="connsiteX15" fmla="*/ 819549 w 912923"/>
+                <a:gd name="connsiteY15" fmla="*/ 654410 h 1225002"/>
+                <a:gd name="connsiteX16" fmla="*/ 816693 w 912923"/>
+                <a:gd name="connsiteY16" fmla="*/ 657266 h 1225002"/>
+                <a:gd name="connsiteX17" fmla="*/ 912923 w 912923"/>
+                <a:gd name="connsiteY17" fmla="*/ 753495 h 1225002"/>
+                <a:gd name="connsiteX18" fmla="*/ 912923 w 912923"/>
+                <a:gd name="connsiteY18" fmla="*/ 953944 h 1225002"/>
+                <a:gd name="connsiteX19" fmla="*/ 820747 w 912923"/>
+                <a:gd name="connsiteY19" fmla="*/ 861768 h 1225002"/>
+                <a:gd name="connsiteX20" fmla="*/ 819545 w 912923"/>
+                <a:gd name="connsiteY20" fmla="*/ 862970 h 1225002"/>
+                <a:gd name="connsiteX21" fmla="*/ 819545 w 912923"/>
+                <a:gd name="connsiteY21" fmla="*/ 859215 h 1225002"/>
+                <a:gd name="connsiteX22" fmla="*/ 643294 w 912923"/>
+                <a:gd name="connsiteY22" fmla="*/ 859215 h 1225002"/>
+                <a:gd name="connsiteX23" fmla="*/ 641268 w 912923"/>
+                <a:gd name="connsiteY23" fmla="*/ 857188 h 1225002"/>
+                <a:gd name="connsiteX24" fmla="*/ 273453 w 912923"/>
+                <a:gd name="connsiteY24" fmla="*/ 1225002 h 1225002"/>
+                <a:gd name="connsiteX25" fmla="*/ 202974 w 912923"/>
+                <a:gd name="connsiteY25" fmla="*/ 1225002 h 1225002"/>
+                <a:gd name="connsiteX26" fmla="*/ 146717 w 912923"/>
+                <a:gd name="connsiteY26" fmla="*/ 1168745 h 1225002"/>
+                <a:gd name="connsiteX27" fmla="*/ 146717 w 912923"/>
+                <a:gd name="connsiteY27" fmla="*/ 1031041 h 1225002"/>
+                <a:gd name="connsiteX28" fmla="*/ 109231 w 912923"/>
+                <a:gd name="connsiteY28" fmla="*/ 993555 h 1225002"/>
+                <a:gd name="connsiteX29" fmla="*/ 108505 w 912923"/>
+                <a:gd name="connsiteY29" fmla="*/ 993555 h 1225002"/>
+                <a:gd name="connsiteX30" fmla="*/ 0 w 912923"/>
+                <a:gd name="connsiteY30" fmla="*/ 885051 h 1225002"/>
+                <a:gd name="connsiteX31" fmla="*/ 0 w 912923"/>
+                <a:gd name="connsiteY31" fmla="*/ 860819 h 1225002"/>
+                <a:gd name="connsiteX32" fmla="*/ 354383 w 912923"/>
+                <a:gd name="connsiteY32" fmla="*/ 506436 h 1225002"/>
+                <a:gd name="connsiteX33" fmla="*/ 350497 w 912923"/>
+                <a:gd name="connsiteY33" fmla="*/ 502550 h 1225002"/>
+                <a:gd name="connsiteX34" fmla="*/ 354383 w 912923"/>
+                <a:gd name="connsiteY34" fmla="*/ 502550 h 1225002"/>
+                <a:gd name="connsiteX35" fmla="*/ 354383 w 912923"/>
+                <a:gd name="connsiteY35" fmla="*/ 393519 h 1225002"/>
+                <a:gd name="connsiteX36" fmla="*/ 440756 w 912923"/>
+                <a:gd name="connsiteY36" fmla="*/ 307146 h 1225002"/>
+                <a:gd name="connsiteX37" fmla="*/ 439168 w 912923"/>
+                <a:gd name="connsiteY37" fmla="*/ 305558 h 1225002"/>
+                <a:gd name="connsiteX38" fmla="*/ 439168 w 912923"/>
+                <a:gd name="connsiteY38" fmla="*/ 215549 h 1225002"/>
+                <a:gd name="connsiteX39" fmla="*/ 503108 w 912923"/>
+                <a:gd name="connsiteY39" fmla="*/ 151609 h 1225002"/>
+                <a:gd name="connsiteX40" fmla="*/ 499865 w 912923"/>
+                <a:gd name="connsiteY40" fmla="*/ 148366 h 1225002"/>
+                <a:gd name="connsiteX41" fmla="*/ 503527 w 912923"/>
+                <a:gd name="connsiteY41" fmla="*/ 148366 h 1225002"/>
+                <a:gd name="connsiteX42" fmla="*/ 503527 w 912923"/>
+                <a:gd name="connsiteY42" fmla="*/ 19191 h 1225002"/>
               </a:gdLst>
               <a:ahLst/>
               <a:cxnLst>
@@ -30758,168 +30748,138 @@
                 <a:cxn ang="0">
                   <a:pos x="connsiteX42" y="connsiteY42"/>
                 </a:cxn>
-                <a:cxn ang="0">
-                  <a:pos x="connsiteX43" y="connsiteY43"/>
-                </a:cxn>
-                <a:cxn ang="0">
-                  <a:pos x="connsiteX44" y="connsiteY44"/>
-                </a:cxn>
-                <a:cxn ang="0">
-                  <a:pos x="connsiteX45" y="connsiteY45"/>
-                </a:cxn>
-                <a:cxn ang="0">
-                  <a:pos x="connsiteX46" y="connsiteY46"/>
-                </a:cxn>
-                <a:cxn ang="0">
-                  <a:pos x="connsiteX47" y="connsiteY47"/>
-                </a:cxn>
               </a:cxnLst>
               <a:rect l="l" t="t" r="r" b="b"/>
               <a:pathLst>
-                <a:path w="1898686" h="2547749">
+                <a:path w="912923" h="1225002">
                   <a:moveTo>
-                    <a:pt x="1087143" y="0"/>
+                    <a:pt x="522718" y="0"/>
                   </a:moveTo>
                   <a:lnTo>
-                    <a:pt x="1209498" y="0"/>
-                  </a:lnTo>
-                  <a:lnTo>
-                    <a:pt x="1307797" y="98299"/>
-                  </a:lnTo>
-                  <a:lnTo>
-                    <a:pt x="1307797" y="246379"/>
-                  </a:lnTo>
-                  <a:lnTo>
-                    <a:pt x="1305368" y="248808"/>
-                  </a:lnTo>
-                  <a:lnTo>
-                    <a:pt x="1415711" y="359151"/>
-                  </a:lnTo>
-                  <a:lnTo>
-                    <a:pt x="1415711" y="541664"/>
-                  </a:lnTo>
-                  <a:lnTo>
-                    <a:pt x="1419634" y="541664"/>
-                  </a:lnTo>
-                  <a:lnTo>
-                    <a:pt x="1412147" y="549151"/>
-                  </a:lnTo>
-                  <a:lnTo>
-                    <a:pt x="1535502" y="672506"/>
-                  </a:lnTo>
-                  <a:lnTo>
-                    <a:pt x="1535502" y="936039"/>
-                  </a:lnTo>
-                  <a:lnTo>
-                    <a:pt x="1537015" y="936039"/>
-                  </a:lnTo>
-                  <a:lnTo>
-                    <a:pt x="1532352" y="940702"/>
-                  </a:lnTo>
-                  <a:lnTo>
-                    <a:pt x="1695450" y="1103800"/>
-                  </a:lnTo>
-                  <a:lnTo>
-                    <a:pt x="1695450" y="1361036"/>
-                  </a:lnTo>
-                  <a:lnTo>
-                    <a:pt x="1704487" y="1361036"/>
-                  </a:lnTo>
-                  <a:lnTo>
-                    <a:pt x="1698548" y="1366975"/>
-                  </a:lnTo>
-                  <a:lnTo>
-                    <a:pt x="1898686" y="1567113"/>
-                  </a:lnTo>
-                  <a:lnTo>
-                    <a:pt x="1898686" y="1984004"/>
-                  </a:lnTo>
-                  <a:lnTo>
-                    <a:pt x="1706979" y="1792297"/>
-                  </a:lnTo>
-                  <a:lnTo>
-                    <a:pt x="1704479" y="1794797"/>
-                  </a:lnTo>
-                  <a:lnTo>
-                    <a:pt x="1704479" y="1786987"/>
-                  </a:lnTo>
-                  <a:lnTo>
-                    <a:pt x="1337915" y="1786987"/>
-                  </a:lnTo>
-                  <a:lnTo>
-                    <a:pt x="1333700" y="1782772"/>
-                  </a:lnTo>
-                  <a:lnTo>
-                    <a:pt x="568723" y="2547749"/>
-                  </a:lnTo>
-                  <a:lnTo>
-                    <a:pt x="422142" y="2547749"/>
-                  </a:lnTo>
-                  <a:lnTo>
-                    <a:pt x="305139" y="2430746"/>
-                  </a:lnTo>
-                  <a:lnTo>
-                    <a:pt x="305139" y="2144350"/>
-                  </a:lnTo>
-                  <a:lnTo>
-                    <a:pt x="227176" y="2066387"/>
-                  </a:lnTo>
-                  <a:lnTo>
-                    <a:pt x="225666" y="2066387"/>
-                  </a:lnTo>
-                  <a:lnTo>
-                    <a:pt x="0" y="1840721"/>
-                  </a:lnTo>
-                  <a:lnTo>
-                    <a:pt x="0" y="1737895"/>
-                  </a:lnTo>
-                  <a:lnTo>
-                    <a:pt x="658932" y="1078963"/>
-                  </a:lnTo>
-                  <a:lnTo>
-                    <a:pt x="661815" y="1078963"/>
-                  </a:lnTo>
-                  <a:lnTo>
-                    <a:pt x="700202" y="1040576"/>
-                  </a:lnTo>
-                  <a:lnTo>
-                    <a:pt x="700202" y="1037693"/>
-                  </a:lnTo>
-                  <a:lnTo>
-                    <a:pt x="702712" y="1035183"/>
-                  </a:lnTo>
-                  <a:lnTo>
-                    <a:pt x="700202" y="1032673"/>
-                  </a:lnTo>
-                  <a:lnTo>
-                    <a:pt x="700202" y="811379"/>
-                  </a:lnTo>
-                  <a:lnTo>
-                    <a:pt x="880958" y="630623"/>
-                  </a:lnTo>
-                  <a:lnTo>
-                    <a:pt x="877394" y="627059"/>
-                  </a:lnTo>
-                  <a:lnTo>
-                    <a:pt x="877394" y="438991"/>
-                  </a:lnTo>
-                  <a:lnTo>
-                    <a:pt x="1003267" y="313118"/>
-                  </a:lnTo>
-                  <a:lnTo>
-                    <a:pt x="1012474" y="313118"/>
-                  </a:lnTo>
-                  <a:lnTo>
-                    <a:pt x="1012474" y="303911"/>
-                  </a:lnTo>
-                  <a:lnTo>
-                    <a:pt x="1016000" y="300385"/>
-                  </a:lnTo>
-                  <a:lnTo>
-                    <a:pt x="1012474" y="296859"/>
-                  </a:lnTo>
-                  <a:lnTo>
-                    <a:pt x="1012474" y="74669"/>
+                    <a:pt x="581549" y="0"/>
+                  </a:lnTo>
+                  <a:lnTo>
+                    <a:pt x="628813" y="47264"/>
+                  </a:lnTo>
+                  <a:lnTo>
+                    <a:pt x="628813" y="118464"/>
+                  </a:lnTo>
+                  <a:lnTo>
+                    <a:pt x="627645" y="119631"/>
+                  </a:lnTo>
+                  <a:lnTo>
+                    <a:pt x="680700" y="172686"/>
+                  </a:lnTo>
+                  <a:lnTo>
+                    <a:pt x="680700" y="260442"/>
+                  </a:lnTo>
+                  <a:lnTo>
+                    <a:pt x="682586" y="260442"/>
+                  </a:lnTo>
+                  <a:lnTo>
+                    <a:pt x="678986" y="264042"/>
+                  </a:lnTo>
+                  <a:lnTo>
+                    <a:pt x="738298" y="323353"/>
+                  </a:lnTo>
+                  <a:lnTo>
+                    <a:pt x="738298" y="450064"/>
+                  </a:lnTo>
+                  <a:lnTo>
+                    <a:pt x="739025" y="450064"/>
+                  </a:lnTo>
+                  <a:lnTo>
+                    <a:pt x="736783" y="452306"/>
+                  </a:lnTo>
+                  <a:lnTo>
+                    <a:pt x="815204" y="530726"/>
+                  </a:lnTo>
+                  <a:lnTo>
+                    <a:pt x="815204" y="654410"/>
+                  </a:lnTo>
+                  <a:lnTo>
+                    <a:pt x="819549" y="654410"/>
+                  </a:lnTo>
+                  <a:lnTo>
+                    <a:pt x="816693" y="657266"/>
+                  </a:lnTo>
+                  <a:lnTo>
+                    <a:pt x="912923" y="753495"/>
+                  </a:lnTo>
+                  <a:lnTo>
+                    <a:pt x="912923" y="953944"/>
+                  </a:lnTo>
+                  <a:lnTo>
+                    <a:pt x="820747" y="861768"/>
+                  </a:lnTo>
+                  <a:lnTo>
+                    <a:pt x="819545" y="862970"/>
+                  </a:lnTo>
+                  <a:lnTo>
+                    <a:pt x="819545" y="859215"/>
+                  </a:lnTo>
+                  <a:lnTo>
+                    <a:pt x="643294" y="859215"/>
+                  </a:lnTo>
+                  <a:lnTo>
+                    <a:pt x="641268" y="857188"/>
+                  </a:lnTo>
+                  <a:lnTo>
+                    <a:pt x="273453" y="1225002"/>
+                  </a:lnTo>
+                  <a:lnTo>
+                    <a:pt x="202974" y="1225002"/>
+                  </a:lnTo>
+                  <a:lnTo>
+                    <a:pt x="146717" y="1168745"/>
+                  </a:lnTo>
+                  <a:lnTo>
+                    <a:pt x="146717" y="1031041"/>
+                  </a:lnTo>
+                  <a:lnTo>
+                    <a:pt x="109231" y="993555"/>
+                  </a:lnTo>
+                  <a:lnTo>
+                    <a:pt x="108505" y="993555"/>
+                  </a:lnTo>
+                  <a:lnTo>
+                    <a:pt x="0" y="885051"/>
+                  </a:lnTo>
+                  <a:lnTo>
+                    <a:pt x="0" y="860819"/>
+                  </a:lnTo>
+                  <a:lnTo>
+                    <a:pt x="354383" y="506436"/>
+                  </a:lnTo>
+                  <a:lnTo>
+                    <a:pt x="350497" y="502550"/>
+                  </a:lnTo>
+                  <a:lnTo>
+                    <a:pt x="354383" y="502550"/>
+                  </a:lnTo>
+                  <a:lnTo>
+                    <a:pt x="354383" y="393519"/>
+                  </a:lnTo>
+                  <a:lnTo>
+                    <a:pt x="440756" y="307146"/>
+                  </a:lnTo>
+                  <a:lnTo>
+                    <a:pt x="439168" y="305558"/>
+                  </a:lnTo>
+                  <a:lnTo>
+                    <a:pt x="439168" y="215549"/>
+                  </a:lnTo>
+                  <a:lnTo>
+                    <a:pt x="503108" y="151609"/>
+                  </a:lnTo>
+                  <a:lnTo>
+                    <a:pt x="499865" y="148366"/>
+                  </a:lnTo>
+                  <a:lnTo>
+                    <a:pt x="503527" y="148366"/>
+                  </a:lnTo>
+                  <a:lnTo>
+                    <a:pt x="503527" y="19191"/>
                   </a:lnTo>
                   <a:close/>
                 </a:path>

</xml_diff>